<commit_message>
Builder: Schalter 'Einfach & schnell halten'
</commit_message>
<xml_diff>
--- a/unterlagen/slides.pptx
+++ b/unterlagen/slides.pptx
@@ -861,7 +861,7 @@
           <a:lstStyle/>
           <a:p>
             <a:r>
-              <a:t>I – Informieren (0:06–0:11). Kurzer, einfacher Input – keine Fachbegriffe. Die vier Punkte nennen, dann kurze Live-Demo. Stoffreduktion: kein Code, kein Deployment.</a:t>
+              <a:t>I – Informieren (0:06–0:11). Kurzer, einfacher Input – keine Fachbegriffe. Die vier Punkte nennen, dann Demo mit einem vorab generierten Beispiel (die Generierung dauert mehrere Minuten – nicht live abwarten). Stoffreduktion: kein Code, kein Deployment.</a:t>
             </a:r>
           </a:p>
         </p:txBody>
@@ -1001,7 +1001,7 @@
           <a:lstStyle/>
           <a:p>
             <a:r>
-              <a:t>I → V. Drei Schritte zeigen, Link/QR teilen, einmal vormachen. Dann übernehmen die Teilnehmenden.</a:t>
+              <a:t>I → V. Drei Schritte zeigen, Link/QR teilen, einmal vormachen. Ergebnis über ein vorab generiertes Beispiel zeigen. Dann übernehmen die Teilnehmenden.</a:t>
             </a:r>
           </a:p>
         </p:txBody>
@@ -1071,7 +1071,7 @@
           <a:lstStyle/>
           <a:p>
             <a:r>
-              <a:t>V – Verarbeiten (0:11–0:19). Aktivste Phase (~8 Min.). Herumgehen, Hilfestellung geben. Plan B bei knapper Zeit: nur ein Live-Beispiel.</a:t>
+              <a:t>V – Verarbeiten (0:11–0:19). Aktivste Phase (~8 Min.). Die Teilnehmenden bauen ihren Prompt und starten die Generierung – sie läuft mehrere Minuten weiter, also nicht abwarten. Herumgehen, Hilfestellung geben. Fertige Ergebnisse später im Gruppenchat teilen.</a:t>
             </a:r>
           </a:p>
         </p:txBody>
@@ -8738,14 +8738,56 @@
                 </a:solidFill>
                 <a:latin typeface="Arial"/>
               </a:rPr>
-              <a:t>1–2 zeigen ihre Website live.</a:t>
-            </a:r>
-          </a:p>
-        </p:txBody>
-      </p:sp>
-      <p:sp>
-        <p:nvSpPr>
-          <p:cNvPr id="17" name="Rectangle 16"/>
+              <a:t>In AI Studio einfügen und starten.</a:t>
+            </a:r>
+          </a:p>
+        </p:txBody>
+      </p:sp>
+      <p:sp>
+        <p:nvSpPr>
+          <p:cNvPr id="17" name="TextBox 16"/>
+          <p:cNvSpPr txBox="1"/>
+          <p:nvPr/>
+        </p:nvSpPr>
+        <p:spPr>
+          <a:xfrm>
+            <a:off x="868680" y="5879592"/>
+            <a:ext cx="6766560" cy="822960"/>
+          </a:xfrm>
+          <a:prstGeom prst="rect">
+            <a:avLst/>
+          </a:prstGeom>
+          <a:noFill/>
+        </p:spPr>
+        <p:txBody>
+          <a:bodyPr wrap="square" anchor="t" lIns="0" rIns="0" tIns="0" bIns="0">
+            <a:spAutoFit/>
+          </a:bodyPr>
+          <a:lstStyle/>
+          <a:p>
+            <a:pPr algn="l">
+              <a:lnSpc>
+                <a:spcPct val="115000"/>
+              </a:lnSpc>
+              <a:spcAft>
+                <a:spcPts val="200"/>
+              </a:spcAft>
+            </a:pPr>
+            <a:r>
+              <a:rPr sz="1300" b="0" i="1">
+                <a:solidFill>
+                  <a:srgbClr val="A1A1AA"/>
+                </a:solidFill>
+                <a:latin typeface="Arial"/>
+              </a:rPr>
+              <a:t>Die Generierung dauert ein paar Minuten — starten, nicht warten. Ergebnis später im Gruppenchat teilen.</a:t>
+            </a:r>
+          </a:p>
+        </p:txBody>
+      </p:sp>
+      <p:sp>
+        <p:nvSpPr>
+          <p:cNvPr id="18" name="Rectangle 17"/>
           <p:cNvSpPr/>
           <p:nvPr/>
         </p:nvSpPr>
@@ -8775,7 +8817,7 @@
       </p:sp>
       <p:pic>
         <p:nvPicPr>
-          <p:cNvPr id="18" name="Picture 17" descr="qr.png"/>
+          <p:cNvPr id="19" name="Picture 18" descr="qr.png"/>
           <p:cNvPicPr>
             <a:picLocks noChangeAspect="1"/>
           </p:cNvPicPr>
@@ -8799,7 +8841,7 @@
       </p:pic>
       <p:sp>
         <p:nvSpPr>
-          <p:cNvPr id="19" name="TextBox 18"/>
+          <p:cNvPr id="20" name="TextBox 19"/>
           <p:cNvSpPr txBox="1"/>
           <p:nvPr/>
         </p:nvSpPr>

</xml_diff>

<commit_message>
Builder: schlanker Modus nutzt Tailwind (Play-CDN) fuer sauberes Layout
</commit_message>
<xml_diff>
--- a/unterlagen/slides.pptx
+++ b/unterlagen/slides.pptx
@@ -651,7 +651,7 @@
           <a:lstStyle/>
           <a:p>
             <a:r>
-              <a:t>A – Ausrichten. Die drei Lernziele in eigenen Worten nennen (nach Mager, beobachtbar). Kurz halten.</a:t>
+              <a:t>R – Reaktivieren (0:03–0:06). Per Handzeichen fragen, wer schon eine KI genutzt hat. Brücke bauen: KI baut ganze Websites. Dialogisch, aktivierend.</a:t>
             </a:r>
           </a:p>
         </p:txBody>
@@ -791,7 +791,7 @@
           <a:lstStyle/>
           <a:p>
             <a:r>
-              <a:t>R – Reaktivieren (0:03–0:06). Per Handzeichen fragen, wer schon eine KI genutzt hat. Brücke bauen: KI baut ganze Websites. Dialogisch, aktivierend.</a:t>
+              <a:t>A – Ausrichten. Die drei Lernziele in eigenen Worten nennen (nach Mager, beobachtbar). Kurz halten.</a:t>
             </a:r>
           </a:p>
         </p:txBody>
@@ -1071,7 +1071,7 @@
           <a:lstStyle/>
           <a:p>
             <a:r>
-              <a:t>V – Verarbeiten (0:11–0:19). Aktivste Phase (~8 Min.). Die Teilnehmenden bauen ihren Prompt und starten die Generierung – sie läuft mehrere Minuten weiter, also nicht abwarten. Herumgehen, Hilfestellung geben. Fertige Ergebnisse später im Gruppenchat teilen.</a:t>
+              <a:t>V – Verarbeiten (0:11–0:19). Aktivste Phase (~8 Min.). Die Teilnehmenden bauen ihren Prompt und starten die Generierung – sie läuft mehrere Minuten weiter, also nicht abwarten. Herumgehen, Hilfestellung geben. Fertige Ergebnisse später im Gruppenchat teilen. Tipp für Einsteiger:innen: den Schalter „Einfach &amp; schnell“ im Baukasten anhaken — schnelleres, überschaubareres Ergebnis.</a:t>
             </a:r>
           </a:p>
         </p:txBody>
@@ -4866,7 +4866,7 @@
             <a:avLst/>
           </a:prstGeom>
           <a:solidFill>
-            <a:srgbClr val="FFFFFF"/>
+            <a:srgbClr val="121316"/>
           </a:solidFill>
           <a:ln>
             <a:noFill/>
@@ -4889,7 +4889,7 @@
         </p:nvSpPr>
         <p:spPr>
           <a:xfrm>
-            <a:off x="868680" y="777240"/>
+            <a:off x="868680" y="1005840"/>
             <a:ext cx="10058400" cy="365760"/>
           </a:xfrm>
           <a:prstGeom prst="rect">
@@ -4911,11 +4911,11 @@
             <a:r>
               <a:rPr sz="1200" b="1" i="0">
                 <a:solidFill>
-                  <a:srgbClr val="71717A"/>
-                </a:solidFill>
-                <a:latin typeface="Arial"/>
-              </a:rPr>
-              <a:t>LERNZIELE · NACH MAGER</a:t>
+                  <a:srgbClr val="A1A1AA"/>
+                </a:solidFill>
+                <a:latin typeface="Arial"/>
+              </a:rPr>
+              <a:t>EINSTIEG &amp; REAKTIVIEREN</a:t>
             </a:r>
           </a:p>
         </p:txBody>
@@ -4928,8 +4928,8 @@
         </p:nvSpPr>
         <p:spPr>
           <a:xfrm>
-            <a:off x="868680" y="1234440"/>
-            <a:ext cx="10424160" cy="822960"/>
+            <a:off x="868680" y="1737360"/>
+            <a:ext cx="10332720" cy="2194560"/>
           </a:xfrm>
           <a:prstGeom prst="rect">
             <a:avLst/>
@@ -4943,18 +4943,49 @@
           <a:lstStyle/>
           <a:p>
             <a:pPr algn="l">
+              <a:lnSpc>
+                <a:spcPct val="112000"/>
+              </a:lnSpc>
               <a:spcAft>
                 <a:spcPts val="200"/>
               </a:spcAft>
             </a:pPr>
             <a:r>
-              <a:rPr sz="3300" b="1" i="0">
-                <a:solidFill>
-                  <a:srgbClr val="121316"/>
-                </a:solidFill>
-                <a:latin typeface="Arial"/>
-              </a:rPr>
-              <a:t>Was ihr danach könnt</a:t>
+              <a:rPr sz="3600" b="1" i="0">
+                <a:solidFill>
+                  <a:srgbClr val="FFFFFF"/>
+                </a:solidFill>
+                <a:latin typeface="Arial"/>
+              </a:rPr>
+              <a:t>„Wer hätte gern eine </a:t>
+            </a:r>
+            <a:r>
+              <a:rPr sz="3600" b="1" i="0">
+                <a:solidFill>
+                  <a:srgbClr val="FFFFFF"/>
+                </a:solidFill>
+                <a:latin typeface="Arial"/>
+              </a:rPr>
+              <a:t>eigene Website</a:t>
+            </a:r>
+          </a:p>
+          <a:p>
+            <a:pPr algn="l">
+              <a:lnSpc>
+                <a:spcPct val="112000"/>
+              </a:lnSpc>
+              <a:spcAft>
+                <a:spcPts val="200"/>
+              </a:spcAft>
+            </a:pPr>
+            <a:r>
+              <a:rPr sz="3600" b="1" i="0">
+                <a:solidFill>
+                  <a:srgbClr val="FFFFFF"/>
+                </a:solidFill>
+                <a:latin typeface="Arial"/>
+              </a:rPr>
+              <a:t>– und wen schreckt der Aufwand ab?“</a:t>
             </a:r>
           </a:p>
         </p:txBody>
@@ -4967,7 +4998,7 @@
         </p:nvCxnSpPr>
         <p:spPr>
           <a:xfrm>
-            <a:off x="868680" y="2468880"/>
+            <a:off x="868680" y="4114800"/>
             <a:ext cx="10469879" cy="0"/>
           </a:xfrm>
           <a:prstGeom prst="line">
@@ -4975,7 +5006,7 @@
           </a:prstGeom>
           <a:ln w="12700">
             <a:solidFill>
-              <a:srgbClr val="E4E4E7"/>
+              <a:srgbClr val="3F3F46"/>
             </a:solidFill>
           </a:ln>
           <a:effectLst/>
@@ -4983,83 +5014,14 @@
       </p:cxnSp>
       <p:sp>
         <p:nvSpPr>
-          <p:cNvPr id="6" name="Oval 5"/>
-          <p:cNvSpPr/>
-          <p:nvPr/>
-        </p:nvSpPr>
-        <p:spPr>
-          <a:xfrm>
-            <a:off x="868680" y="2761488"/>
-            <a:ext cx="548640" cy="548640"/>
-          </a:xfrm>
-          <a:prstGeom prst="ellipse">
-            <a:avLst/>
-          </a:prstGeom>
-          <a:noFill/>
-          <a:ln w="16510">
-            <a:solidFill>
-              <a:srgbClr val="121316"/>
-            </a:solidFill>
-          </a:ln>
-          <a:effectLst/>
-        </p:spPr>
-        <p:txBody>
-          <a:bodyPr rtlCol="0" anchor="ctr"/>
-          <a:lstStyle/>
-          <a:p>
-            <a:pPr algn="ctr"/>
-          </a:p>
-        </p:txBody>
-      </p:sp>
-      <p:sp>
-        <p:nvSpPr>
-          <p:cNvPr id="7" name="TextBox 6"/>
+          <p:cNvPr id="6" name="TextBox 5"/>
           <p:cNvSpPr txBox="1"/>
           <p:nvPr/>
         </p:nvSpPr>
         <p:spPr>
           <a:xfrm>
-            <a:off x="868680" y="2734056"/>
-            <a:ext cx="548640" cy="548640"/>
-          </a:xfrm>
-          <a:prstGeom prst="rect">
-            <a:avLst/>
-          </a:prstGeom>
-          <a:noFill/>
-        </p:spPr>
-        <p:txBody>
-          <a:bodyPr wrap="square" anchor="ctr" lIns="0" rIns="0" tIns="0" bIns="0">
-            <a:spAutoFit/>
-          </a:bodyPr>
-          <a:lstStyle/>
-          <a:p>
-            <a:pPr algn="ctr">
-              <a:spcAft>
-                <a:spcPts val="200"/>
-              </a:spcAft>
-            </a:pPr>
-            <a:r>
-              <a:rPr sz="1400" b="1" i="0">
-                <a:solidFill>
-                  <a:srgbClr val="121316"/>
-                </a:solidFill>
-                <a:latin typeface="Arial"/>
-              </a:rPr>
-              <a:t>1</a:t>
-            </a:r>
-          </a:p>
-        </p:txBody>
-      </p:sp>
-      <p:sp>
-        <p:nvSpPr>
-          <p:cNvPr id="8" name="TextBox 7"/>
-          <p:cNvSpPr txBox="1"/>
-          <p:nvPr/>
-        </p:nvSpPr>
-        <p:spPr>
-          <a:xfrm>
-            <a:off x="1737360" y="2724912"/>
-            <a:ext cx="9509760" cy="1005840"/>
+            <a:off x="868680" y="4434840"/>
+            <a:ext cx="10332720" cy="1828800"/>
           </a:xfrm>
           <a:prstGeom prst="rect">
             <a:avLst/>
@@ -5074,17 +5036,17 @@
           <a:p>
             <a:pPr algn="l">
               <a:spcAft>
-                <a:spcPts val="300"/>
-              </a:spcAft>
-            </a:pPr>
-            <a:r>
-              <a:rPr sz="2000" b="1" i="0">
-                <a:solidFill>
-                  <a:srgbClr val="121316"/>
-                </a:solidFill>
-                <a:latin typeface="Arial"/>
-              </a:rPr>
-              <a:t>Erklären, was Google AI Studio ist</a:t>
+                <a:spcPts val="1000"/>
+              </a:spcAft>
+            </a:pPr>
+            <a:r>
+              <a:rPr sz="1900" b="0" i="0">
+                <a:solidFill>
+                  <a:srgbClr val="E7E7EA"/>
+                </a:solidFill>
+                <a:latin typeface="Arial"/>
+              </a:rPr>
+              <a:t>Wer hat schon einmal eine KI (z. B. ChatGPT) gefragt?</a:t>
             </a:r>
           </a:p>
           <a:p>
@@ -5094,331 +5056,26 @@
               </a:spcAft>
             </a:pPr>
             <a:r>
-              <a:rPr sz="1400" b="0" i="0">
-                <a:solidFill>
-                  <a:srgbClr val="71717A"/>
-                </a:solidFill>
-                <a:latin typeface="Arial"/>
-              </a:rPr>
-              <a:t>Zwei Beispiele nennen, was man damit bauen kann.</a:t>
-            </a:r>
-          </a:p>
-        </p:txBody>
-      </p:sp>
-      <p:cxnSp>
-        <p:nvCxnSpPr>
-          <p:cNvPr id="9" name="Connector 8"/>
-          <p:cNvCxnSpPr/>
-          <p:nvPr/>
-        </p:nvCxnSpPr>
-        <p:spPr>
-          <a:xfrm>
-            <a:off x="868680" y="3749039"/>
-            <a:ext cx="10469879" cy="0"/>
-          </a:xfrm>
-          <a:prstGeom prst="line">
-            <a:avLst/>
-          </a:prstGeom>
-          <a:ln w="12700">
-            <a:solidFill>
-              <a:srgbClr val="E4E4E7"/>
-            </a:solidFill>
-          </a:ln>
-          <a:effectLst/>
-        </p:spPr>
-      </p:cxnSp>
-      <p:sp>
-        <p:nvSpPr>
-          <p:cNvPr id="10" name="Oval 9"/>
-          <p:cNvSpPr/>
-          <p:nvPr/>
-        </p:nvSpPr>
-        <p:spPr>
-          <a:xfrm>
-            <a:off x="868680" y="4041648"/>
-            <a:ext cx="548640" cy="548640"/>
-          </a:xfrm>
-          <a:prstGeom prst="ellipse">
-            <a:avLst/>
-          </a:prstGeom>
-          <a:noFill/>
-          <a:ln w="16510">
-            <a:solidFill>
-              <a:srgbClr val="121316"/>
-            </a:solidFill>
-          </a:ln>
-          <a:effectLst/>
-        </p:spPr>
-        <p:txBody>
-          <a:bodyPr rtlCol="0" anchor="ctr"/>
-          <a:lstStyle/>
-          <a:p>
-            <a:pPr algn="ctr"/>
-          </a:p>
-        </p:txBody>
-      </p:sp>
-      <p:sp>
-        <p:nvSpPr>
-          <p:cNvPr id="11" name="TextBox 10"/>
-          <p:cNvSpPr txBox="1"/>
-          <p:nvPr/>
-        </p:nvSpPr>
-        <p:spPr>
-          <a:xfrm>
-            <a:off x="868680" y="4014215"/>
-            <a:ext cx="548640" cy="548640"/>
-          </a:xfrm>
-          <a:prstGeom prst="rect">
-            <a:avLst/>
-          </a:prstGeom>
-          <a:noFill/>
-        </p:spPr>
-        <p:txBody>
-          <a:bodyPr wrap="square" anchor="ctr" lIns="0" rIns="0" tIns="0" bIns="0">
-            <a:spAutoFit/>
-          </a:bodyPr>
-          <a:lstStyle/>
-          <a:p>
-            <a:pPr algn="ctr">
-              <a:spcAft>
-                <a:spcPts val="200"/>
-              </a:spcAft>
-            </a:pPr>
-            <a:r>
-              <a:rPr sz="1400" b="1" i="0">
-                <a:solidFill>
-                  <a:srgbClr val="121316"/>
-                </a:solidFill>
-                <a:latin typeface="Arial"/>
-              </a:rPr>
-              <a:t>2</a:t>
-            </a:r>
-          </a:p>
-        </p:txBody>
-      </p:sp>
-      <p:sp>
-        <p:nvSpPr>
-          <p:cNvPr id="12" name="TextBox 11"/>
-          <p:cNvSpPr txBox="1"/>
-          <p:nvPr/>
-        </p:nvSpPr>
-        <p:spPr>
-          <a:xfrm>
-            <a:off x="1737360" y="4005072"/>
-            <a:ext cx="9509760" cy="1005840"/>
-          </a:xfrm>
-          <a:prstGeom prst="rect">
-            <a:avLst/>
-          </a:prstGeom>
-          <a:noFill/>
-        </p:spPr>
-        <p:txBody>
-          <a:bodyPr wrap="square" anchor="t" lIns="0" rIns="0" tIns="0" bIns="0">
-            <a:spAutoFit/>
-          </a:bodyPr>
-          <a:lstStyle/>
-          <a:p>
-            <a:pPr algn="l">
-              <a:spcAft>
-                <a:spcPts val="300"/>
-              </a:spcAft>
-            </a:pPr>
-            <a:r>
-              <a:rPr sz="2000" b="1" i="0">
-                <a:solidFill>
-                  <a:srgbClr val="121316"/>
-                </a:solidFill>
-                <a:latin typeface="Arial"/>
-              </a:rPr>
-              <a:t>Einen Website-Auftrag bauen</a:t>
-            </a:r>
-          </a:p>
-          <a:p>
-            <a:pPr algn="l">
-              <a:spcAft>
-                <a:spcPts val="200"/>
-              </a:spcAft>
-            </a:pPr>
-            <a:r>
-              <a:rPr sz="1400" b="0" i="0">
-                <a:solidFill>
-                  <a:srgbClr val="71717A"/>
-                </a:solidFill>
-                <a:latin typeface="Arial"/>
-              </a:rPr>
-              <a:t>Mit dem Baukasten einen klaren Prompt zusammenstellen.</a:t>
-            </a:r>
-          </a:p>
-        </p:txBody>
-      </p:sp>
-      <p:cxnSp>
-        <p:nvCxnSpPr>
-          <p:cNvPr id="13" name="Connector 12"/>
-          <p:cNvCxnSpPr/>
-          <p:nvPr/>
-        </p:nvCxnSpPr>
-        <p:spPr>
-          <a:xfrm>
-            <a:off x="868680" y="5029200"/>
-            <a:ext cx="10469879" cy="0"/>
-          </a:xfrm>
-          <a:prstGeom prst="line">
-            <a:avLst/>
-          </a:prstGeom>
-          <a:ln w="12700">
-            <a:solidFill>
-              <a:srgbClr val="E4E4E7"/>
-            </a:solidFill>
-          </a:ln>
-          <a:effectLst/>
-        </p:spPr>
-      </p:cxnSp>
-      <p:sp>
-        <p:nvSpPr>
-          <p:cNvPr id="14" name="Oval 13"/>
-          <p:cNvSpPr/>
-          <p:nvPr/>
-        </p:nvSpPr>
-        <p:spPr>
-          <a:xfrm>
-            <a:off x="868680" y="5321808"/>
-            <a:ext cx="548640" cy="548640"/>
-          </a:xfrm>
-          <a:prstGeom prst="ellipse">
-            <a:avLst/>
-          </a:prstGeom>
-          <a:noFill/>
-          <a:ln w="16510">
-            <a:solidFill>
-              <a:srgbClr val="121316"/>
-            </a:solidFill>
-          </a:ln>
-          <a:effectLst/>
-        </p:spPr>
-        <p:txBody>
-          <a:bodyPr rtlCol="0" anchor="ctr"/>
-          <a:lstStyle/>
-          <a:p>
-            <a:pPr algn="ctr"/>
-          </a:p>
-        </p:txBody>
-      </p:sp>
-      <p:sp>
-        <p:nvSpPr>
-          <p:cNvPr id="15" name="TextBox 14"/>
-          <p:cNvSpPr txBox="1"/>
-          <p:nvPr/>
-        </p:nvSpPr>
-        <p:spPr>
-          <a:xfrm>
-            <a:off x="868680" y="5294376"/>
-            <a:ext cx="548640" cy="548640"/>
-          </a:xfrm>
-          <a:prstGeom prst="rect">
-            <a:avLst/>
-          </a:prstGeom>
-          <a:noFill/>
-        </p:spPr>
-        <p:txBody>
-          <a:bodyPr wrap="square" anchor="ctr" lIns="0" rIns="0" tIns="0" bIns="0">
-            <a:spAutoFit/>
-          </a:bodyPr>
-          <a:lstStyle/>
-          <a:p>
-            <a:pPr algn="ctr">
-              <a:spcAft>
-                <a:spcPts val="200"/>
-              </a:spcAft>
-            </a:pPr>
-            <a:r>
-              <a:rPr sz="1400" b="1" i="0">
-                <a:solidFill>
-                  <a:srgbClr val="121316"/>
-                </a:solidFill>
-                <a:latin typeface="Arial"/>
-              </a:rPr>
-              <a:t>3</a:t>
-            </a:r>
-          </a:p>
-        </p:txBody>
-      </p:sp>
-      <p:sp>
-        <p:nvSpPr>
-          <p:cNvPr id="16" name="TextBox 15"/>
-          <p:cNvSpPr txBox="1"/>
-          <p:nvPr/>
-        </p:nvSpPr>
-        <p:spPr>
-          <a:xfrm>
-            <a:off x="1737360" y="5285232"/>
-            <a:ext cx="9509760" cy="1005840"/>
-          </a:xfrm>
-          <a:prstGeom prst="rect">
-            <a:avLst/>
-          </a:prstGeom>
-          <a:noFill/>
-        </p:spPr>
-        <p:txBody>
-          <a:bodyPr wrap="square" anchor="t" lIns="0" rIns="0" tIns="0" bIns="0">
-            <a:spAutoFit/>
-          </a:bodyPr>
-          <a:lstStyle/>
-          <a:p>
-            <a:pPr algn="l">
-              <a:spcAft>
-                <a:spcPts val="300"/>
-              </a:spcAft>
-            </a:pPr>
-            <a:r>
-              <a:rPr sz="2000" b="1" i="0">
-                <a:solidFill>
-                  <a:srgbClr val="121316"/>
-                </a:solidFill>
-                <a:latin typeface="Arial"/>
-              </a:rPr>
-              <a:t>Eine erste Website erzeugen</a:t>
-            </a:r>
-          </a:p>
-          <a:p>
-            <a:pPr algn="l">
-              <a:spcAft>
-                <a:spcPts val="200"/>
-              </a:spcAft>
-            </a:pPr>
-            <a:r>
-              <a:rPr sz="1400" b="0" i="0">
-                <a:solidFill>
-                  <a:srgbClr val="71717A"/>
-                </a:solidFill>
-                <a:latin typeface="Arial"/>
-              </a:rPr>
-              <a:t>Prompt in AI Studio einfügen, Vorschau sehen.</a:t>
-            </a:r>
-          </a:p>
-        </p:txBody>
-      </p:sp>
-      <p:cxnSp>
-        <p:nvCxnSpPr>
-          <p:cNvPr id="17" name="Connector 16"/>
-          <p:cNvCxnSpPr/>
-          <p:nvPr/>
-        </p:nvCxnSpPr>
-        <p:spPr>
-          <a:xfrm>
-            <a:off x="868680" y="6309360"/>
-            <a:ext cx="10469879" cy="0"/>
-          </a:xfrm>
-          <a:prstGeom prst="line">
-            <a:avLst/>
-          </a:prstGeom>
-          <a:ln w="12700">
-            <a:solidFill>
-              <a:srgbClr val="E4E4E7"/>
-            </a:solidFill>
-          </a:ln>
-          <a:effectLst/>
-        </p:spPr>
-      </p:cxnSp>
+              <a:rPr sz="1900" b="0" i="0">
+                <a:solidFill>
+                  <a:srgbClr val="E7E7EA"/>
+                </a:solidFill>
+                <a:latin typeface="Arial"/>
+              </a:rPr>
+              <a:t>KI schreibt nicht nur Texte – sie baut ganze </a:t>
+            </a:r>
+            <a:r>
+              <a:rPr sz="1900" b="1" i="0">
+                <a:solidFill>
+                  <a:srgbClr val="FFFFFF"/>
+                </a:solidFill>
+                <a:latin typeface="Arial"/>
+              </a:rPr>
+              <a:t>Websites.</a:t>
+            </a:r>
+          </a:p>
+        </p:txBody>
+      </p:sp>
     </p:spTree>
   </p:cSld>
   <p:clrMapOvr>
@@ -6329,7 +5986,7 @@
             <a:avLst/>
           </a:prstGeom>
           <a:solidFill>
-            <a:srgbClr val="121316"/>
+            <a:srgbClr val="FFFFFF"/>
           </a:solidFill>
           <a:ln>
             <a:noFill/>
@@ -6352,7 +6009,7 @@
         </p:nvSpPr>
         <p:spPr>
           <a:xfrm>
-            <a:off x="868680" y="1005840"/>
+            <a:off x="868680" y="777240"/>
             <a:ext cx="10058400" cy="365760"/>
           </a:xfrm>
           <a:prstGeom prst="rect">
@@ -6374,11 +6031,11 @@
             <a:r>
               <a:rPr sz="1200" b="1" i="0">
                 <a:solidFill>
-                  <a:srgbClr val="A1A1AA"/>
-                </a:solidFill>
-                <a:latin typeface="Arial"/>
-              </a:rPr>
-              <a:t>EINSTIEG &amp; REAKTIVIEREN</a:t>
+                  <a:srgbClr val="71717A"/>
+                </a:solidFill>
+                <a:latin typeface="Arial"/>
+              </a:rPr>
+              <a:t>LERNZIELE · NACH MAGER</a:t>
             </a:r>
           </a:p>
         </p:txBody>
@@ -6391,8 +6048,8 @@
         </p:nvSpPr>
         <p:spPr>
           <a:xfrm>
-            <a:off x="868680" y="1737360"/>
-            <a:ext cx="10332720" cy="2194560"/>
+            <a:off x="868680" y="1234440"/>
+            <a:ext cx="10424160" cy="822960"/>
           </a:xfrm>
           <a:prstGeom prst="rect">
             <a:avLst/>
@@ -6406,49 +6063,18 @@
           <a:lstStyle/>
           <a:p>
             <a:pPr algn="l">
-              <a:lnSpc>
-                <a:spcPct val="112000"/>
-              </a:lnSpc>
               <a:spcAft>
                 <a:spcPts val="200"/>
               </a:spcAft>
             </a:pPr>
             <a:r>
-              <a:rPr sz="3600" b="1" i="0">
-                <a:solidFill>
-                  <a:srgbClr val="FFFFFF"/>
-                </a:solidFill>
-                <a:latin typeface="Arial"/>
-              </a:rPr>
-              <a:t>„Wer hätte gern eine </a:t>
-            </a:r>
-            <a:r>
-              <a:rPr sz="3600" b="1" i="0">
-                <a:solidFill>
-                  <a:srgbClr val="FFFFFF"/>
-                </a:solidFill>
-                <a:latin typeface="Arial"/>
-              </a:rPr>
-              <a:t>eigene Website</a:t>
-            </a:r>
-          </a:p>
-          <a:p>
-            <a:pPr algn="l">
-              <a:lnSpc>
-                <a:spcPct val="112000"/>
-              </a:lnSpc>
-              <a:spcAft>
-                <a:spcPts val="200"/>
-              </a:spcAft>
-            </a:pPr>
-            <a:r>
-              <a:rPr sz="3600" b="1" i="0">
-                <a:solidFill>
-                  <a:srgbClr val="FFFFFF"/>
-                </a:solidFill>
-                <a:latin typeface="Arial"/>
-              </a:rPr>
-              <a:t>– und wen schreckt der Aufwand ab?“</a:t>
+              <a:rPr sz="3300" b="1" i="0">
+                <a:solidFill>
+                  <a:srgbClr val="121316"/>
+                </a:solidFill>
+                <a:latin typeface="Arial"/>
+              </a:rPr>
+              <a:t>Was ihr danach könnt</a:t>
             </a:r>
           </a:p>
         </p:txBody>
@@ -6461,7 +6087,7 @@
         </p:nvCxnSpPr>
         <p:spPr>
           <a:xfrm>
-            <a:off x="868680" y="4114800"/>
+            <a:off x="868680" y="2468880"/>
             <a:ext cx="10469879" cy="0"/>
           </a:xfrm>
           <a:prstGeom prst="line">
@@ -6469,7 +6095,7 @@
           </a:prstGeom>
           <a:ln w="12700">
             <a:solidFill>
-              <a:srgbClr val="3F3F46"/>
+              <a:srgbClr val="E4E4E7"/>
             </a:solidFill>
           </a:ln>
           <a:effectLst/>
@@ -6477,14 +6103,83 @@
       </p:cxnSp>
       <p:sp>
         <p:nvSpPr>
-          <p:cNvPr id="6" name="TextBox 5"/>
+          <p:cNvPr id="6" name="Oval 5"/>
+          <p:cNvSpPr/>
+          <p:nvPr/>
+        </p:nvSpPr>
+        <p:spPr>
+          <a:xfrm>
+            <a:off x="868680" y="2761488"/>
+            <a:ext cx="548640" cy="548640"/>
+          </a:xfrm>
+          <a:prstGeom prst="ellipse">
+            <a:avLst/>
+          </a:prstGeom>
+          <a:noFill/>
+          <a:ln w="16510">
+            <a:solidFill>
+              <a:srgbClr val="121316"/>
+            </a:solidFill>
+          </a:ln>
+          <a:effectLst/>
+        </p:spPr>
+        <p:txBody>
+          <a:bodyPr rtlCol="0" anchor="ctr"/>
+          <a:lstStyle/>
+          <a:p>
+            <a:pPr algn="ctr"/>
+          </a:p>
+        </p:txBody>
+      </p:sp>
+      <p:sp>
+        <p:nvSpPr>
+          <p:cNvPr id="7" name="TextBox 6"/>
           <p:cNvSpPr txBox="1"/>
           <p:nvPr/>
         </p:nvSpPr>
         <p:spPr>
           <a:xfrm>
-            <a:off x="868680" y="4434840"/>
-            <a:ext cx="10332720" cy="1828800"/>
+            <a:off x="868680" y="2734056"/>
+            <a:ext cx="548640" cy="548640"/>
+          </a:xfrm>
+          <a:prstGeom prst="rect">
+            <a:avLst/>
+          </a:prstGeom>
+          <a:noFill/>
+        </p:spPr>
+        <p:txBody>
+          <a:bodyPr wrap="square" anchor="ctr" lIns="0" rIns="0" tIns="0" bIns="0">
+            <a:spAutoFit/>
+          </a:bodyPr>
+          <a:lstStyle/>
+          <a:p>
+            <a:pPr algn="ctr">
+              <a:spcAft>
+                <a:spcPts val="200"/>
+              </a:spcAft>
+            </a:pPr>
+            <a:r>
+              <a:rPr sz="1400" b="1" i="0">
+                <a:solidFill>
+                  <a:srgbClr val="121316"/>
+                </a:solidFill>
+                <a:latin typeface="Arial"/>
+              </a:rPr>
+              <a:t>1</a:t>
+            </a:r>
+          </a:p>
+        </p:txBody>
+      </p:sp>
+      <p:sp>
+        <p:nvSpPr>
+          <p:cNvPr id="8" name="TextBox 7"/>
+          <p:cNvSpPr txBox="1"/>
+          <p:nvPr/>
+        </p:nvSpPr>
+        <p:spPr>
+          <a:xfrm>
+            <a:off x="1737360" y="2724912"/>
+            <a:ext cx="9509760" cy="1005840"/>
           </a:xfrm>
           <a:prstGeom prst="rect">
             <a:avLst/>
@@ -6499,17 +6194,17 @@
           <a:p>
             <a:pPr algn="l">
               <a:spcAft>
-                <a:spcPts val="1000"/>
-              </a:spcAft>
-            </a:pPr>
-            <a:r>
-              <a:rPr sz="1900" b="0" i="0">
-                <a:solidFill>
-                  <a:srgbClr val="E7E7EA"/>
-                </a:solidFill>
-                <a:latin typeface="Arial"/>
-              </a:rPr>
-              <a:t>Wer hat schon einmal eine KI (z. B. ChatGPT) gefragt?</a:t>
+                <a:spcPts val="300"/>
+              </a:spcAft>
+            </a:pPr>
+            <a:r>
+              <a:rPr sz="2000" b="1" i="0">
+                <a:solidFill>
+                  <a:srgbClr val="121316"/>
+                </a:solidFill>
+                <a:latin typeface="Arial"/>
+              </a:rPr>
+              <a:t>Erklären, was Google AI Studio ist</a:t>
             </a:r>
           </a:p>
           <a:p>
@@ -6519,26 +6214,331 @@
               </a:spcAft>
             </a:pPr>
             <a:r>
-              <a:rPr sz="1900" b="0" i="0">
-                <a:solidFill>
-                  <a:srgbClr val="E7E7EA"/>
-                </a:solidFill>
-                <a:latin typeface="Arial"/>
-              </a:rPr>
-              <a:t>KI schreibt nicht nur Texte – sie baut ganze </a:t>
-            </a:r>
-            <a:r>
-              <a:rPr sz="1900" b="1" i="0">
-                <a:solidFill>
-                  <a:srgbClr val="FFFFFF"/>
-                </a:solidFill>
-                <a:latin typeface="Arial"/>
-              </a:rPr>
-              <a:t>Websites.</a:t>
-            </a:r>
-          </a:p>
-        </p:txBody>
-      </p:sp>
+              <a:rPr sz="1400" b="0" i="0">
+                <a:solidFill>
+                  <a:srgbClr val="71717A"/>
+                </a:solidFill>
+                <a:latin typeface="Arial"/>
+              </a:rPr>
+              <a:t>Zwei Beispiele nennen, was man damit bauen kann.</a:t>
+            </a:r>
+          </a:p>
+        </p:txBody>
+      </p:sp>
+      <p:cxnSp>
+        <p:nvCxnSpPr>
+          <p:cNvPr id="9" name="Connector 8"/>
+          <p:cNvCxnSpPr/>
+          <p:nvPr/>
+        </p:nvCxnSpPr>
+        <p:spPr>
+          <a:xfrm>
+            <a:off x="868680" y="3749039"/>
+            <a:ext cx="10469879" cy="0"/>
+          </a:xfrm>
+          <a:prstGeom prst="line">
+            <a:avLst/>
+          </a:prstGeom>
+          <a:ln w="12700">
+            <a:solidFill>
+              <a:srgbClr val="E4E4E7"/>
+            </a:solidFill>
+          </a:ln>
+          <a:effectLst/>
+        </p:spPr>
+      </p:cxnSp>
+      <p:sp>
+        <p:nvSpPr>
+          <p:cNvPr id="10" name="Oval 9"/>
+          <p:cNvSpPr/>
+          <p:nvPr/>
+        </p:nvSpPr>
+        <p:spPr>
+          <a:xfrm>
+            <a:off x="868680" y="4041648"/>
+            <a:ext cx="548640" cy="548640"/>
+          </a:xfrm>
+          <a:prstGeom prst="ellipse">
+            <a:avLst/>
+          </a:prstGeom>
+          <a:noFill/>
+          <a:ln w="16510">
+            <a:solidFill>
+              <a:srgbClr val="121316"/>
+            </a:solidFill>
+          </a:ln>
+          <a:effectLst/>
+        </p:spPr>
+        <p:txBody>
+          <a:bodyPr rtlCol="0" anchor="ctr"/>
+          <a:lstStyle/>
+          <a:p>
+            <a:pPr algn="ctr"/>
+          </a:p>
+        </p:txBody>
+      </p:sp>
+      <p:sp>
+        <p:nvSpPr>
+          <p:cNvPr id="11" name="TextBox 10"/>
+          <p:cNvSpPr txBox="1"/>
+          <p:nvPr/>
+        </p:nvSpPr>
+        <p:spPr>
+          <a:xfrm>
+            <a:off x="868680" y="4014215"/>
+            <a:ext cx="548640" cy="548640"/>
+          </a:xfrm>
+          <a:prstGeom prst="rect">
+            <a:avLst/>
+          </a:prstGeom>
+          <a:noFill/>
+        </p:spPr>
+        <p:txBody>
+          <a:bodyPr wrap="square" anchor="ctr" lIns="0" rIns="0" tIns="0" bIns="0">
+            <a:spAutoFit/>
+          </a:bodyPr>
+          <a:lstStyle/>
+          <a:p>
+            <a:pPr algn="ctr">
+              <a:spcAft>
+                <a:spcPts val="200"/>
+              </a:spcAft>
+            </a:pPr>
+            <a:r>
+              <a:rPr sz="1400" b="1" i="0">
+                <a:solidFill>
+                  <a:srgbClr val="121316"/>
+                </a:solidFill>
+                <a:latin typeface="Arial"/>
+              </a:rPr>
+              <a:t>2</a:t>
+            </a:r>
+          </a:p>
+        </p:txBody>
+      </p:sp>
+      <p:sp>
+        <p:nvSpPr>
+          <p:cNvPr id="12" name="TextBox 11"/>
+          <p:cNvSpPr txBox="1"/>
+          <p:nvPr/>
+        </p:nvSpPr>
+        <p:spPr>
+          <a:xfrm>
+            <a:off x="1737360" y="4005072"/>
+            <a:ext cx="9509760" cy="1005840"/>
+          </a:xfrm>
+          <a:prstGeom prst="rect">
+            <a:avLst/>
+          </a:prstGeom>
+          <a:noFill/>
+        </p:spPr>
+        <p:txBody>
+          <a:bodyPr wrap="square" anchor="t" lIns="0" rIns="0" tIns="0" bIns="0">
+            <a:spAutoFit/>
+          </a:bodyPr>
+          <a:lstStyle/>
+          <a:p>
+            <a:pPr algn="l">
+              <a:spcAft>
+                <a:spcPts val="300"/>
+              </a:spcAft>
+            </a:pPr>
+            <a:r>
+              <a:rPr sz="2000" b="1" i="0">
+                <a:solidFill>
+                  <a:srgbClr val="121316"/>
+                </a:solidFill>
+                <a:latin typeface="Arial"/>
+              </a:rPr>
+              <a:t>Einen Website-Auftrag bauen</a:t>
+            </a:r>
+          </a:p>
+          <a:p>
+            <a:pPr algn="l">
+              <a:spcAft>
+                <a:spcPts val="200"/>
+              </a:spcAft>
+            </a:pPr>
+            <a:r>
+              <a:rPr sz="1400" b="0" i="0">
+                <a:solidFill>
+                  <a:srgbClr val="71717A"/>
+                </a:solidFill>
+                <a:latin typeface="Arial"/>
+              </a:rPr>
+              <a:t>Mit dem Baukasten einen klaren Prompt zusammenstellen.</a:t>
+            </a:r>
+          </a:p>
+        </p:txBody>
+      </p:sp>
+      <p:cxnSp>
+        <p:nvCxnSpPr>
+          <p:cNvPr id="13" name="Connector 12"/>
+          <p:cNvCxnSpPr/>
+          <p:nvPr/>
+        </p:nvCxnSpPr>
+        <p:spPr>
+          <a:xfrm>
+            <a:off x="868680" y="5029200"/>
+            <a:ext cx="10469879" cy="0"/>
+          </a:xfrm>
+          <a:prstGeom prst="line">
+            <a:avLst/>
+          </a:prstGeom>
+          <a:ln w="12700">
+            <a:solidFill>
+              <a:srgbClr val="E4E4E7"/>
+            </a:solidFill>
+          </a:ln>
+          <a:effectLst/>
+        </p:spPr>
+      </p:cxnSp>
+      <p:sp>
+        <p:nvSpPr>
+          <p:cNvPr id="14" name="Oval 13"/>
+          <p:cNvSpPr/>
+          <p:nvPr/>
+        </p:nvSpPr>
+        <p:spPr>
+          <a:xfrm>
+            <a:off x="868680" y="5321808"/>
+            <a:ext cx="548640" cy="548640"/>
+          </a:xfrm>
+          <a:prstGeom prst="ellipse">
+            <a:avLst/>
+          </a:prstGeom>
+          <a:noFill/>
+          <a:ln w="16510">
+            <a:solidFill>
+              <a:srgbClr val="121316"/>
+            </a:solidFill>
+          </a:ln>
+          <a:effectLst/>
+        </p:spPr>
+        <p:txBody>
+          <a:bodyPr rtlCol="0" anchor="ctr"/>
+          <a:lstStyle/>
+          <a:p>
+            <a:pPr algn="ctr"/>
+          </a:p>
+        </p:txBody>
+      </p:sp>
+      <p:sp>
+        <p:nvSpPr>
+          <p:cNvPr id="15" name="TextBox 14"/>
+          <p:cNvSpPr txBox="1"/>
+          <p:nvPr/>
+        </p:nvSpPr>
+        <p:spPr>
+          <a:xfrm>
+            <a:off x="868680" y="5294376"/>
+            <a:ext cx="548640" cy="548640"/>
+          </a:xfrm>
+          <a:prstGeom prst="rect">
+            <a:avLst/>
+          </a:prstGeom>
+          <a:noFill/>
+        </p:spPr>
+        <p:txBody>
+          <a:bodyPr wrap="square" anchor="ctr" lIns="0" rIns="0" tIns="0" bIns="0">
+            <a:spAutoFit/>
+          </a:bodyPr>
+          <a:lstStyle/>
+          <a:p>
+            <a:pPr algn="ctr">
+              <a:spcAft>
+                <a:spcPts val="200"/>
+              </a:spcAft>
+            </a:pPr>
+            <a:r>
+              <a:rPr sz="1400" b="1" i="0">
+                <a:solidFill>
+                  <a:srgbClr val="121316"/>
+                </a:solidFill>
+                <a:latin typeface="Arial"/>
+              </a:rPr>
+              <a:t>3</a:t>
+            </a:r>
+          </a:p>
+        </p:txBody>
+      </p:sp>
+      <p:sp>
+        <p:nvSpPr>
+          <p:cNvPr id="16" name="TextBox 15"/>
+          <p:cNvSpPr txBox="1"/>
+          <p:nvPr/>
+        </p:nvSpPr>
+        <p:spPr>
+          <a:xfrm>
+            <a:off x="1737360" y="5285232"/>
+            <a:ext cx="9509760" cy="1005840"/>
+          </a:xfrm>
+          <a:prstGeom prst="rect">
+            <a:avLst/>
+          </a:prstGeom>
+          <a:noFill/>
+        </p:spPr>
+        <p:txBody>
+          <a:bodyPr wrap="square" anchor="t" lIns="0" rIns="0" tIns="0" bIns="0">
+            <a:spAutoFit/>
+          </a:bodyPr>
+          <a:lstStyle/>
+          <a:p>
+            <a:pPr algn="l">
+              <a:spcAft>
+                <a:spcPts val="300"/>
+              </a:spcAft>
+            </a:pPr>
+            <a:r>
+              <a:rPr sz="2000" b="1" i="0">
+                <a:solidFill>
+                  <a:srgbClr val="121316"/>
+                </a:solidFill>
+                <a:latin typeface="Arial"/>
+              </a:rPr>
+              <a:t>Eine erste Website erzeugen</a:t>
+            </a:r>
+          </a:p>
+          <a:p>
+            <a:pPr algn="l">
+              <a:spcAft>
+                <a:spcPts val="200"/>
+              </a:spcAft>
+            </a:pPr>
+            <a:r>
+              <a:rPr sz="1400" b="0" i="0">
+                <a:solidFill>
+                  <a:srgbClr val="71717A"/>
+                </a:solidFill>
+                <a:latin typeface="Arial"/>
+              </a:rPr>
+              <a:t>Prompt in AI Studio einfügen, Vorschau sehen.</a:t>
+            </a:r>
+          </a:p>
+        </p:txBody>
+      </p:sp>
+      <p:cxnSp>
+        <p:nvCxnSpPr>
+          <p:cNvPr id="17" name="Connector 16"/>
+          <p:cNvCxnSpPr/>
+          <p:nvPr/>
+        </p:nvCxnSpPr>
+        <p:spPr>
+          <a:xfrm>
+            <a:off x="868680" y="6309360"/>
+            <a:ext cx="10469879" cy="0"/>
+          </a:xfrm>
+          <a:prstGeom prst="line">
+            <a:avLst/>
+          </a:prstGeom>
+          <a:ln w="12700">
+            <a:solidFill>
+              <a:srgbClr val="E4E4E7"/>
+            </a:solidFill>
+          </a:ln>
+          <a:effectLst/>
+        </p:spPr>
+      </p:cxnSp>
     </p:spTree>
   </p:cSld>
   <p:clrMapOvr>
@@ -7547,7 +7547,7 @@
         <p:spPr>
           <a:xfrm>
             <a:off x="868680" y="1234440"/>
-            <a:ext cx="7315200" cy="822960"/>
+            <a:ext cx="10424160" cy="822960"/>
           </a:xfrm>
           <a:prstGeom prst="rect">
             <a:avLst/>
@@ -7585,8 +7585,8 @@
         </p:nvCxnSpPr>
         <p:spPr>
           <a:xfrm>
-            <a:off x="868680" y="2468880"/>
-            <a:ext cx="6766560" cy="0"/>
+            <a:off x="868680" y="2651760"/>
+            <a:ext cx="10469879" cy="0"/>
           </a:xfrm>
           <a:prstGeom prst="line">
             <a:avLst/>
@@ -7607,8 +7607,8 @@
         </p:nvSpPr>
         <p:spPr>
           <a:xfrm>
-            <a:off x="868680" y="2706624"/>
-            <a:ext cx="502920" cy="502920"/>
+            <a:off x="868680" y="2926079"/>
+            <a:ext cx="548640" cy="548640"/>
           </a:xfrm>
           <a:prstGeom prst="ellipse">
             <a:avLst/>
@@ -7637,8 +7637,8 @@
         </p:nvSpPr>
         <p:spPr>
           <a:xfrm>
-            <a:off x="868680" y="2679192"/>
-            <a:ext cx="502920" cy="502920"/>
+            <a:off x="868680" y="2898648"/>
+            <a:ext cx="548640" cy="548640"/>
           </a:xfrm>
           <a:prstGeom prst="rect">
             <a:avLst/>
@@ -7657,7 +7657,7 @@
               </a:spcAft>
             </a:pPr>
             <a:r>
-              <a:rPr sz="1300" b="1" i="0">
+              <a:rPr sz="1400" b="1" i="0">
                 <a:solidFill>
                   <a:srgbClr val="121316"/>
                 </a:solidFill>
@@ -7676,8 +7676,8 @@
         </p:nvSpPr>
         <p:spPr>
           <a:xfrm>
-            <a:off x="1691640" y="2651760"/>
-            <a:ext cx="5760720" cy="914400"/>
+            <a:off x="1737360" y="2871215"/>
+            <a:ext cx="9418320" cy="914400"/>
           </a:xfrm>
           <a:prstGeom prst="rect">
             <a:avLst/>
@@ -7692,33 +7692,33 @@
           <a:p>
             <a:pPr algn="l">
               <a:spcAft>
+                <a:spcPts val="300"/>
+              </a:spcAft>
+            </a:pPr>
+            <a:r>
+              <a:rPr sz="2000" b="1" i="0">
+                <a:solidFill>
+                  <a:srgbClr val="121316"/>
+                </a:solidFill>
+                <a:latin typeface="Arial"/>
+              </a:rPr>
+              <a:t>Baukasten ausfüllen</a:t>
+            </a:r>
+          </a:p>
+          <a:p>
+            <a:pPr algn="l">
+              <a:spcAft>
                 <a:spcPts val="200"/>
               </a:spcAft>
             </a:pPr>
             <a:r>
-              <a:rPr sz="1800" b="1" i="0">
-                <a:solidFill>
-                  <a:srgbClr val="121316"/>
-                </a:solidFill>
-                <a:latin typeface="Arial"/>
-              </a:rPr>
-              <a:t>Baukasten ausfüllen</a:t>
-            </a:r>
-          </a:p>
-          <a:p>
-            <a:pPr algn="l">
-              <a:spcAft>
-                <a:spcPts val="200"/>
-              </a:spcAft>
-            </a:pPr>
-            <a:r>
-              <a:rPr sz="1300" b="0" i="0">
+              <a:rPr sz="1400" b="0" i="0">
                 <a:solidFill>
                   <a:srgbClr val="71717A"/>
                 </a:solidFill>
                 <a:latin typeface="Arial"/>
               </a:rPr>
-              <a:t>Fragen beantworten – der Prompt entsteht.</a:t>
+              <a:t>Fragen beantworten – der Prompt entsteht automatisch.</a:t>
             </a:r>
           </a:p>
         </p:txBody>
@@ -7731,8 +7731,8 @@
         </p:nvCxnSpPr>
         <p:spPr>
           <a:xfrm>
-            <a:off x="868680" y="3520440"/>
-            <a:ext cx="6766560" cy="0"/>
+            <a:off x="868680" y="3794760"/>
+            <a:ext cx="10469879" cy="0"/>
           </a:xfrm>
           <a:prstGeom prst="line">
             <a:avLst/>
@@ -7753,8 +7753,8 @@
         </p:nvSpPr>
         <p:spPr>
           <a:xfrm>
-            <a:off x="868680" y="3758184"/>
-            <a:ext cx="502920" cy="502920"/>
+            <a:off x="868680" y="4069080"/>
+            <a:ext cx="548640" cy="548640"/>
           </a:xfrm>
           <a:prstGeom prst="ellipse">
             <a:avLst/>
@@ -7783,8 +7783,8 @@
         </p:nvSpPr>
         <p:spPr>
           <a:xfrm>
-            <a:off x="868680" y="3730752"/>
-            <a:ext cx="502920" cy="502920"/>
+            <a:off x="868680" y="4041648"/>
+            <a:ext cx="548640" cy="548640"/>
           </a:xfrm>
           <a:prstGeom prst="rect">
             <a:avLst/>
@@ -7803,7 +7803,7 @@
               </a:spcAft>
             </a:pPr>
             <a:r>
-              <a:rPr sz="1300" b="1" i="0">
+              <a:rPr sz="1400" b="1" i="0">
                 <a:solidFill>
                   <a:srgbClr val="121316"/>
                 </a:solidFill>
@@ -7822,8 +7822,8 @@
         </p:nvSpPr>
         <p:spPr>
           <a:xfrm>
-            <a:off x="1691640" y="3703320"/>
-            <a:ext cx="5760720" cy="914400"/>
+            <a:off x="1737360" y="4014216"/>
+            <a:ext cx="9418320" cy="914400"/>
           </a:xfrm>
           <a:prstGeom prst="rect">
             <a:avLst/>
@@ -7838,33 +7838,33 @@
           <a:p>
             <a:pPr algn="l">
               <a:spcAft>
+                <a:spcPts val="300"/>
+              </a:spcAft>
+            </a:pPr>
+            <a:r>
+              <a:rPr sz="2000" b="1" i="0">
+                <a:solidFill>
+                  <a:srgbClr val="121316"/>
+                </a:solidFill>
+                <a:latin typeface="Arial"/>
+              </a:rPr>
+              <a:t>Prompt kopieren</a:t>
+            </a:r>
+          </a:p>
+          <a:p>
+            <a:pPr algn="l">
+              <a:spcAft>
                 <a:spcPts val="200"/>
               </a:spcAft>
             </a:pPr>
             <a:r>
-              <a:rPr sz="1800" b="1" i="0">
-                <a:solidFill>
-                  <a:srgbClr val="121316"/>
-                </a:solidFill>
-                <a:latin typeface="Arial"/>
-              </a:rPr>
-              <a:t>Prompt kopieren</a:t>
-            </a:r>
-          </a:p>
-          <a:p>
-            <a:pPr algn="l">
-              <a:spcAft>
-                <a:spcPts val="200"/>
-              </a:spcAft>
-            </a:pPr>
-            <a:r>
-              <a:rPr sz="1300" b="0" i="0">
+              <a:rPr sz="1400" b="0" i="0">
                 <a:solidFill>
                   <a:srgbClr val="71717A"/>
                 </a:solidFill>
                 <a:latin typeface="Arial"/>
               </a:rPr>
-              <a:t>Ein Klick.</a:t>
+              <a:t>Ein Klick auf „Prompt kopieren“.</a:t>
             </a:r>
           </a:p>
         </p:txBody>
@@ -7877,8 +7877,8 @@
         </p:nvCxnSpPr>
         <p:spPr>
           <a:xfrm>
-            <a:off x="868680" y="4572000"/>
-            <a:ext cx="6766560" cy="0"/>
+            <a:off x="868680" y="4937760"/>
+            <a:ext cx="10469879" cy="0"/>
           </a:xfrm>
           <a:prstGeom prst="line">
             <a:avLst/>
@@ -7899,8 +7899,8 @@
         </p:nvSpPr>
         <p:spPr>
           <a:xfrm>
-            <a:off x="868680" y="4809744"/>
-            <a:ext cx="502920" cy="502920"/>
+            <a:off x="868680" y="5212080"/>
+            <a:ext cx="548640" cy="548640"/>
           </a:xfrm>
           <a:prstGeom prst="ellipse">
             <a:avLst/>
@@ -7929,8 +7929,8 @@
         </p:nvSpPr>
         <p:spPr>
           <a:xfrm>
-            <a:off x="868680" y="4782312"/>
-            <a:ext cx="502920" cy="502920"/>
+            <a:off x="868680" y="5184648"/>
+            <a:ext cx="548640" cy="548640"/>
           </a:xfrm>
           <a:prstGeom prst="rect">
             <a:avLst/>
@@ -7949,7 +7949,7 @@
               </a:spcAft>
             </a:pPr>
             <a:r>
-              <a:rPr sz="1300" b="1" i="0">
+              <a:rPr sz="1400" b="1" i="0">
                 <a:solidFill>
                   <a:srgbClr val="121316"/>
                 </a:solidFill>
@@ -7968,8 +7968,8 @@
         </p:nvSpPr>
         <p:spPr>
           <a:xfrm>
-            <a:off x="1691640" y="4754880"/>
-            <a:ext cx="5760720" cy="914400"/>
+            <a:off x="1737360" y="5157216"/>
+            <a:ext cx="9418320" cy="914400"/>
           </a:xfrm>
           <a:prstGeom prst="rect">
             <a:avLst/>
@@ -7984,33 +7984,33 @@
           <a:p>
             <a:pPr algn="l">
               <a:spcAft>
+                <a:spcPts val="300"/>
+              </a:spcAft>
+            </a:pPr>
+            <a:r>
+              <a:rPr sz="2000" b="1" i="0">
+                <a:solidFill>
+                  <a:srgbClr val="121316"/>
+                </a:solidFill>
+                <a:latin typeface="Arial"/>
+              </a:rPr>
+              <a:t>In AI Studio einfügen</a:t>
+            </a:r>
+          </a:p>
+          <a:p>
+            <a:pPr algn="l">
+              <a:spcAft>
                 <a:spcPts val="200"/>
               </a:spcAft>
             </a:pPr>
             <a:r>
-              <a:rPr sz="1800" b="1" i="0">
-                <a:solidFill>
-                  <a:srgbClr val="121316"/>
-                </a:solidFill>
-                <a:latin typeface="Arial"/>
-              </a:rPr>
-              <a:t>In AI Studio einfügen</a:t>
-            </a:r>
-          </a:p>
-          <a:p>
-            <a:pPr algn="l">
-              <a:spcAft>
-                <a:spcPts val="200"/>
-              </a:spcAft>
-            </a:pPr>
-            <a:r>
-              <a:rPr sz="1300" b="0" i="0">
+              <a:rPr sz="1400" b="0" i="0">
                 <a:solidFill>
                   <a:srgbClr val="71717A"/>
                 </a:solidFill>
                 <a:latin typeface="Arial"/>
               </a:rPr>
-              <a:t>Einfügen, abschicken, Vorschau.</a:t>
+              <a:t>Einfügen, abschicken – die Vorschau erscheint.</a:t>
             </a:r>
           </a:p>
         </p:txBody>
@@ -8023,8 +8023,8 @@
         </p:nvCxnSpPr>
         <p:spPr>
           <a:xfrm>
-            <a:off x="868680" y="5623560"/>
-            <a:ext cx="6766560" cy="0"/>
+            <a:off x="868680" y="6080760"/>
+            <a:ext cx="10469879" cy="0"/>
           </a:xfrm>
           <a:prstGeom prst="line">
             <a:avLst/>
@@ -8037,154 +8037,6 @@
           <a:effectLst/>
         </p:spPr>
       </p:cxnSp>
-      <p:sp>
-        <p:nvSpPr>
-          <p:cNvPr id="18" name="Rectangle 17"/>
-          <p:cNvSpPr/>
-          <p:nvPr/>
-        </p:nvSpPr>
-        <p:spPr>
-          <a:xfrm>
-            <a:off x="8732520" y="2468880"/>
-            <a:ext cx="2606040" cy="3246120"/>
-          </a:xfrm>
-          <a:prstGeom prst="rect">
-            <a:avLst/>
-          </a:prstGeom>
-          <a:noFill/>
-          <a:ln w="12700">
-            <a:solidFill>
-              <a:srgbClr val="E4E4E7"/>
-            </a:solidFill>
-          </a:ln>
-          <a:effectLst/>
-        </p:spPr>
-        <p:txBody>
-          <a:bodyPr rtlCol="0" anchor="ctr"/>
-          <a:lstStyle/>
-          <a:p>
-            <a:pPr algn="ctr"/>
-          </a:p>
-        </p:txBody>
-      </p:sp>
-      <p:sp>
-        <p:nvSpPr>
-          <p:cNvPr id="19" name="TextBox 18"/>
-          <p:cNvSpPr txBox="1"/>
-          <p:nvPr/>
-        </p:nvSpPr>
-        <p:spPr>
-          <a:xfrm>
-            <a:off x="8732520" y="2697480"/>
-            <a:ext cx="2606040" cy="365760"/>
-          </a:xfrm>
-          <a:prstGeom prst="rect">
-            <a:avLst/>
-          </a:prstGeom>
-          <a:noFill/>
-        </p:spPr>
-        <p:txBody>
-          <a:bodyPr wrap="square" anchor="t" lIns="0" rIns="0" tIns="0" bIns="0">
-            <a:spAutoFit/>
-          </a:bodyPr>
-          <a:lstStyle/>
-          <a:p>
-            <a:pPr algn="ctr">
-              <a:spcAft>
-                <a:spcPts val="200"/>
-              </a:spcAft>
-            </a:pPr>
-            <a:r>
-              <a:rPr sz="1100" b="1" i="0">
-                <a:solidFill>
-                  <a:srgbClr val="71717A"/>
-                </a:solidFill>
-                <a:latin typeface="Arial"/>
-              </a:rPr>
-              <a:t>SCANNEN</a:t>
-            </a:r>
-          </a:p>
-        </p:txBody>
-      </p:sp>
-      <p:pic>
-        <p:nvPicPr>
-          <p:cNvPr id="20" name="Picture 19" descr="qr.png"/>
-          <p:cNvPicPr>
-            <a:picLocks noChangeAspect="1"/>
-          </p:cNvPicPr>
-          <p:nvPr/>
-        </p:nvPicPr>
-        <p:blipFill>
-          <a:blip r:embed="rId2"/>
-          <a:stretch>
-            <a:fillRect/>
-          </a:stretch>
-        </p:blipFill>
-        <p:spPr>
-          <a:xfrm>
-            <a:off x="9390888" y="3108960"/>
-            <a:ext cx="1280160" cy="1280160"/>
-          </a:xfrm>
-          <a:prstGeom prst="rect">
-            <a:avLst/>
-          </a:prstGeom>
-        </p:spPr>
-      </p:pic>
-      <p:sp>
-        <p:nvSpPr>
-          <p:cNvPr id="21" name="TextBox 20"/>
-          <p:cNvSpPr txBox="1"/>
-          <p:nvPr/>
-        </p:nvSpPr>
-        <p:spPr>
-          <a:xfrm>
-            <a:off x="8823960" y="4617720"/>
-            <a:ext cx="2423160" cy="1005840"/>
-          </a:xfrm>
-          <a:prstGeom prst="rect">
-            <a:avLst/>
-          </a:prstGeom>
-          <a:noFill/>
-        </p:spPr>
-        <p:txBody>
-          <a:bodyPr wrap="square" anchor="t" lIns="0" rIns="0" tIns="0" bIns="0">
-            <a:spAutoFit/>
-          </a:bodyPr>
-          <a:lstStyle/>
-          <a:p>
-            <a:pPr algn="ctr">
-              <a:spcAft>
-                <a:spcPts val="200"/>
-              </a:spcAft>
-            </a:pPr>
-            <a:r>
-              <a:rPr sz="1100" b="1" i="0">
-                <a:solidFill>
-                  <a:srgbClr val="2563EB"/>
-                </a:solidFill>
-                <a:latin typeface="Arial"/>
-              </a:rPr>
-              <a:t>criseone.github.io/</a:t>
-            </a:r>
-          </a:p>
-          <a:p>
-            <a:pPr algn="ctr">
-              <a:spcAft>
-                <a:spcPts val="200"/>
-              </a:spcAft>
-            </a:pPr>
-            <a:r>
-              <a:rPr sz="1100" b="1" i="0">
-                <a:solidFill>
-                  <a:srgbClr val="2563EB"/>
-                </a:solidFill>
-                <a:latin typeface="Arial"/>
-              </a:rPr>
-              <a:t>meine-website-ai-studio</a:t>
-            </a:r>
-          </a:p>
-        </p:txBody>
-      </p:sp>
     </p:spTree>
   </p:cSld>
   <p:clrMapOvr>

</xml_diff>

<commit_message>
Feinplanung auf Slides abgestimmt (Inhalte, Reihenfolge, Zeiten 3+3+5+8+4)
</commit_message>
<xml_diff>
--- a/unterlagen/slides.pptx
+++ b/unterlagen/slides.pptx
@@ -6,9 +6,9 @@
   </p:sldMasterIdLst>
   <p:sldIdLst>
     <p:sldId id="256" r:id="rId7"/>
-    <p:sldId id="257" r:id="rId8"/>
     <p:sldId id="258" r:id="rId9"/>
     <p:sldId id="259" r:id="rId10"/>
+    <p:sldId id="257" r:id="rId8"/>
     <p:sldId id="260" r:id="rId11"/>
     <p:sldId id="261" r:id="rId12"/>
     <p:sldId id="262" r:id="rId13"/>
@@ -511,7 +511,7 @@
           <a:lstStyle/>
           <a:p>
             <a:r>
-              <a:t>A – Ausrichten (0:00–0:03). Begrüssen, kurz persönlich abholen: Wer hätte gern eine eigene Website? Thema und Dauer nennen, betonen: heute geht es ums selbst Ausprobieren.</a:t>
+              <a:t>A – Ausrichten (0:00–0:03). Begrüssen, kurz persönlich abholen: Wer hätte gern eine eigene Website? Thema und Dauer nennen, betonen: heute geht es ums selbst Ausprobieren. Gleich zu Beginn live eine Website starten (vorbereiteter Prompt, „Go“ drücken) — sie baut im Hintergrund und wird am Schluss enthüllt (so ist die ganze Lektion die Wartezeit). Fuchs Communications im zweiten Tab als Backup.</a:t>
             </a:r>
           </a:p>
         </p:txBody>
@@ -1071,7 +1071,7 @@
           <a:lstStyle/>
           <a:p>
             <a:r>
-              <a:t>V – Verarbeiten (0:11–0:19). Aktivste Phase (~8 Min.). Die Teilnehmenden bauen ihren Prompt und starten die Generierung – sie läuft mehrere Minuten weiter, also nicht abwarten. Herumgehen, Hilfestellung geben. Fertige Ergebnisse später im Gruppenchat teilen. Tipp für Einsteiger:innen: den Schalter „Einfach &amp; schnell“ im Baukasten anhaken — schnelleres, überschaubareres Ergebnis.</a:t>
+              <a:t>V – Verarbeiten (0:11–0:19). Aktivste Phase (~8 Min.). Die Teilnehmenden bauen ihren Prompt und starten die Generierung – sie läuft mehrere Minuten weiter, also nicht abwarten. Herumgehen, Hilfestellung geben. Fertige Ergebnisse später im Gruppenchat teilen. Wartezeit für einen kurzen Austausch zur eigenen Idee nutzen.</a:t>
             </a:r>
           </a:p>
         </p:txBody>
@@ -1141,7 +1141,7 @@
           <a:lstStyle/>
           <a:p>
             <a:r>
-              <a:t>A – Auswerten (0:19–0:23). Lernzielkontrolle: drei Schritte und zwei Bau-Beispiele nennen lassen (Murmelrunde). Fragen zulassen.</a:t>
+              <a:t>A – Auswerten (0:19–0:23). Zuerst die zu Beginn gestartete Website enthüllen (Aha-Moment). Dann Lernzielkontrolle: drei Schritte und zwei Bau-Beispiele nennen lassen (Murmelrunde). Fragen zulassen. Ergebnisse der TN später im Gruppenchat. Backup: Fuchs Communications zeigen, falls die Live-Website nicht fertig oder fehlerhaft ist.</a:t>
             </a:r>
           </a:p>
         </p:txBody>
@@ -4311,7 +4311,7 @@
                 </a:solidFill>
                 <a:latin typeface="Arial"/>
               </a:rPr>
-              <a:t>Ohne Programmieren – beschreiben, die KI baut.</a:t>
+              <a:t>Wie baut man 2026 eine Website — oder eine App?</a:t>
             </a:r>
           </a:p>
         </p:txBody>
@@ -4372,7 +4372,7 @@
                 </a:solidFill>
                 <a:latin typeface="Arial"/>
               </a:rPr>
-              <a:t>20–25 Min.      Absolute Einsteiger:innen      Name / Datum: ______________</a:t>
+              <a:t>20–25 Min.      Absolute Einsteiger:innen      Tim Fuchs · 05.09.2026</a:t>
             </a:r>
           </a:p>
         </p:txBody>
@@ -4475,7 +4475,7 @@
                 </a:solidFill>
                 <a:latin typeface="Arial"/>
               </a:rPr>
-              <a:t>Eure Website ist nur einen Prompt entfernt.</a:t>
+              <a:t>Eure Websites sind fertig oder gerade noch am Bauen — und ihr wisst jetzt, wie es geht.</a:t>
             </a:r>
           </a:p>
         </p:txBody>
@@ -4621,7 +4621,7 @@
                 </a:solidFill>
                 <a:latin typeface="Arial"/>
               </a:rPr>
-              <a:t>Kurz herumgehen, Ideen holen.</a:t>
+              <a:t>Fertig oder in Arbeit — kurz herumgehen, Ideen holen.</a:t>
             </a:r>
           </a:p>
         </p:txBody>
@@ -4866,7 +4866,7 @@
             <a:avLst/>
           </a:prstGeom>
           <a:solidFill>
-            <a:srgbClr val="121316"/>
+            <a:srgbClr val="FFFFFF"/>
           </a:solidFill>
           <a:ln>
             <a:noFill/>
@@ -4889,7 +4889,7 @@
         </p:nvSpPr>
         <p:spPr>
           <a:xfrm>
-            <a:off x="868680" y="1005840"/>
+            <a:off x="868680" y="777240"/>
             <a:ext cx="10058400" cy="365760"/>
           </a:xfrm>
           <a:prstGeom prst="rect">
@@ -4911,11 +4911,11 @@
             <a:r>
               <a:rPr sz="1200" b="1" i="0">
                 <a:solidFill>
-                  <a:srgbClr val="A1A1AA"/>
-                </a:solidFill>
-                <a:latin typeface="Arial"/>
-              </a:rPr>
-              <a:t>EINSTIEG &amp; REAKTIVIEREN</a:t>
+                  <a:srgbClr val="71717A"/>
+                </a:solidFill>
+                <a:latin typeface="Arial"/>
+              </a:rPr>
+              <a:t>ABLAUF · ARIVA</a:t>
             </a:r>
           </a:p>
         </p:txBody>
@@ -4928,8 +4928,8 @@
         </p:nvSpPr>
         <p:spPr>
           <a:xfrm>
-            <a:off x="868680" y="1737360"/>
-            <a:ext cx="10332720" cy="2194560"/>
+            <a:off x="868680" y="1234440"/>
+            <a:ext cx="10424160" cy="822960"/>
           </a:xfrm>
           <a:prstGeom prst="rect">
             <a:avLst/>
@@ -4943,49 +4943,18 @@
           <a:lstStyle/>
           <a:p>
             <a:pPr algn="l">
-              <a:lnSpc>
-                <a:spcPct val="112000"/>
-              </a:lnSpc>
               <a:spcAft>
                 <a:spcPts val="200"/>
               </a:spcAft>
             </a:pPr>
             <a:r>
-              <a:rPr sz="3600" b="1" i="0">
-                <a:solidFill>
-                  <a:srgbClr val="FFFFFF"/>
-                </a:solidFill>
-                <a:latin typeface="Arial"/>
-              </a:rPr>
-              <a:t>„Wer hätte gern eine </a:t>
-            </a:r>
-            <a:r>
-              <a:rPr sz="3600" b="1" i="0">
-                <a:solidFill>
-                  <a:srgbClr val="FFFFFF"/>
-                </a:solidFill>
-                <a:latin typeface="Arial"/>
-              </a:rPr>
-              <a:t>eigene Website</a:t>
-            </a:r>
-          </a:p>
-          <a:p>
-            <a:pPr algn="l">
-              <a:lnSpc>
-                <a:spcPct val="112000"/>
-              </a:lnSpc>
-              <a:spcAft>
-                <a:spcPts val="200"/>
-              </a:spcAft>
-            </a:pPr>
-            <a:r>
-              <a:rPr sz="3600" b="1" i="0">
-                <a:solidFill>
-                  <a:srgbClr val="FFFFFF"/>
-                </a:solidFill>
-                <a:latin typeface="Arial"/>
-              </a:rPr>
-              <a:t>– und wen schreckt der Aufwand ab?“</a:t>
+              <a:rPr sz="3300" b="1" i="0">
+                <a:solidFill>
+                  <a:srgbClr val="121316"/>
+                </a:solidFill>
+                <a:latin typeface="Arial"/>
+              </a:rPr>
+              <a:t>So läuft die Lektion</a:t>
             </a:r>
           </a:p>
         </p:txBody>
@@ -4998,7 +4967,7 @@
         </p:nvCxnSpPr>
         <p:spPr>
           <a:xfrm>
-            <a:off x="868680" y="4114800"/>
+            <a:off x="868680" y="2331720"/>
             <a:ext cx="10469879" cy="0"/>
           </a:xfrm>
           <a:prstGeom prst="line">
@@ -5006,7 +4975,7 @@
           </a:prstGeom>
           <a:ln w="12700">
             <a:solidFill>
-              <a:srgbClr val="3F3F46"/>
+              <a:srgbClr val="E4E4E7"/>
             </a:solidFill>
           </a:ln>
           <a:effectLst/>
@@ -5020,8 +4989,8 @@
         </p:nvSpPr>
         <p:spPr>
           <a:xfrm>
-            <a:off x="868680" y="4434840"/>
-            <a:ext cx="10332720" cy="1828800"/>
+            <a:off x="978407" y="2651760"/>
+            <a:ext cx="1874519" cy="822960"/>
           </a:xfrm>
           <a:prstGeom prst="rect">
             <a:avLst/>
@@ -5036,42 +5005,707 @@
           <a:p>
             <a:pPr algn="l">
               <a:spcAft>
-                <a:spcPts val="1000"/>
-              </a:spcAft>
-            </a:pPr>
-            <a:r>
-              <a:rPr sz="1900" b="0" i="0">
-                <a:solidFill>
-                  <a:srgbClr val="E7E7EA"/>
-                </a:solidFill>
-                <a:latin typeface="Arial"/>
-              </a:rPr>
-              <a:t>Wer hat schon einmal eine KI (z. B. ChatGPT) gefragt?</a:t>
-            </a:r>
-          </a:p>
+                <a:spcPts val="200"/>
+              </a:spcAft>
+            </a:pPr>
+            <a:r>
+              <a:rPr sz="3400" b="1" i="0">
+                <a:solidFill>
+                  <a:srgbClr val="121316"/>
+                </a:solidFill>
+                <a:latin typeface="Arial"/>
+              </a:rPr>
+              <a:t>A</a:t>
+            </a:r>
+          </a:p>
+        </p:txBody>
+      </p:sp>
+      <p:sp>
+        <p:nvSpPr>
+          <p:cNvPr id="7" name="TextBox 6"/>
+          <p:cNvSpPr txBox="1"/>
+          <p:nvPr/>
+        </p:nvSpPr>
+        <p:spPr>
+          <a:xfrm>
+            <a:off x="978407" y="3520439"/>
+            <a:ext cx="1874519" cy="1645920"/>
+          </a:xfrm>
+          <a:prstGeom prst="rect">
+            <a:avLst/>
+          </a:prstGeom>
+          <a:noFill/>
+        </p:spPr>
+        <p:txBody>
+          <a:bodyPr wrap="square" anchor="t" lIns="0" rIns="0" tIns="0" bIns="0">
+            <a:spAutoFit/>
+          </a:bodyPr>
+          <a:lstStyle/>
           <a:p>
             <a:pPr algn="l">
+              <a:lnSpc>
+                <a:spcPct val="100000"/>
+              </a:lnSpc>
+              <a:spcAft>
+                <a:spcPts val="300"/>
+              </a:spcAft>
+            </a:pPr>
+            <a:r>
+              <a:rPr sz="1500" b="1" i="0">
+                <a:solidFill>
+                  <a:srgbClr val="121316"/>
+                </a:solidFill>
+                <a:latin typeface="Arial"/>
+              </a:rPr>
+              <a:t>Ausrichten</a:t>
+            </a:r>
+          </a:p>
+          <a:p>
+            <a:pPr algn="l">
+              <a:spcAft>
+                <a:spcPts val="500"/>
+              </a:spcAft>
+            </a:pPr>
+            <a:r>
+              <a:rPr sz="1400" b="1" i="0">
+                <a:solidFill>
+                  <a:srgbClr val="71717A"/>
+                </a:solidFill>
+                <a:latin typeface="Arial"/>
+              </a:rPr>
+              <a:t>3′</a:t>
+            </a:r>
+          </a:p>
+          <a:p>
+            <a:pPr algn="l">
+              <a:lnSpc>
+                <a:spcPct val="105000"/>
+              </a:lnSpc>
               <a:spcAft>
                 <a:spcPts val="200"/>
               </a:spcAft>
             </a:pPr>
             <a:r>
-              <a:rPr sz="1900" b="0" i="0">
-                <a:solidFill>
-                  <a:srgbClr val="E7E7EA"/>
-                </a:solidFill>
-                <a:latin typeface="Arial"/>
-              </a:rPr>
-              <a:t>KI schreibt nicht nur Texte – sie baut ganze </a:t>
-            </a:r>
-            <a:r>
-              <a:rPr sz="1900" b="1" i="0">
-                <a:solidFill>
-                  <a:srgbClr val="FFFFFF"/>
-                </a:solidFill>
-                <a:latin typeface="Arial"/>
-              </a:rPr>
-              <a:t>Websites.</a:t>
+              <a:rPr sz="1200" b="0" i="0">
+                <a:solidFill>
+                  <a:srgbClr val="71717A"/>
+                </a:solidFill>
+                <a:latin typeface="Arial"/>
+              </a:rPr>
+              <a:t>Ziele &amp; Ablauf</a:t>
+            </a:r>
+          </a:p>
+        </p:txBody>
+      </p:sp>
+      <p:cxnSp>
+        <p:nvCxnSpPr>
+          <p:cNvPr id="8" name="Connector 7"/>
+          <p:cNvCxnSpPr/>
+          <p:nvPr/>
+        </p:nvCxnSpPr>
+        <p:spPr>
+          <a:xfrm>
+            <a:off x="2962656" y="2514600"/>
+            <a:ext cx="0" cy="2743200"/>
+          </a:xfrm>
+          <a:prstGeom prst="line">
+            <a:avLst/>
+          </a:prstGeom>
+          <a:ln w="12700">
+            <a:solidFill>
+              <a:srgbClr val="E4E4E7"/>
+            </a:solidFill>
+          </a:ln>
+          <a:effectLst/>
+        </p:spPr>
+      </p:cxnSp>
+      <p:sp>
+        <p:nvSpPr>
+          <p:cNvPr id="9" name="TextBox 8"/>
+          <p:cNvSpPr txBox="1"/>
+          <p:nvPr/>
+        </p:nvSpPr>
+        <p:spPr>
+          <a:xfrm>
+            <a:off x="3072384" y="2651760"/>
+            <a:ext cx="1874519" cy="822960"/>
+          </a:xfrm>
+          <a:prstGeom prst="rect">
+            <a:avLst/>
+          </a:prstGeom>
+          <a:noFill/>
+        </p:spPr>
+        <p:txBody>
+          <a:bodyPr wrap="square" anchor="t" lIns="0" rIns="0" tIns="0" bIns="0">
+            <a:spAutoFit/>
+          </a:bodyPr>
+          <a:lstStyle/>
+          <a:p>
+            <a:pPr algn="l">
+              <a:spcAft>
+                <a:spcPts val="200"/>
+              </a:spcAft>
+            </a:pPr>
+            <a:r>
+              <a:rPr sz="3400" b="1" i="0">
+                <a:solidFill>
+                  <a:srgbClr val="121316"/>
+                </a:solidFill>
+                <a:latin typeface="Arial"/>
+              </a:rPr>
+              <a:t>R</a:t>
+            </a:r>
+          </a:p>
+        </p:txBody>
+      </p:sp>
+      <p:sp>
+        <p:nvSpPr>
+          <p:cNvPr id="10" name="TextBox 9"/>
+          <p:cNvSpPr txBox="1"/>
+          <p:nvPr/>
+        </p:nvSpPr>
+        <p:spPr>
+          <a:xfrm>
+            <a:off x="3072384" y="3520439"/>
+            <a:ext cx="1874519" cy="1645920"/>
+          </a:xfrm>
+          <a:prstGeom prst="rect">
+            <a:avLst/>
+          </a:prstGeom>
+          <a:noFill/>
+        </p:spPr>
+        <p:txBody>
+          <a:bodyPr wrap="square" anchor="t" lIns="0" rIns="0" tIns="0" bIns="0">
+            <a:spAutoFit/>
+          </a:bodyPr>
+          <a:lstStyle/>
+          <a:p>
+            <a:pPr algn="l">
+              <a:lnSpc>
+                <a:spcPct val="100000"/>
+              </a:lnSpc>
+              <a:spcAft>
+                <a:spcPts val="300"/>
+              </a:spcAft>
+            </a:pPr>
+            <a:r>
+              <a:rPr sz="1500" b="1" i="0">
+                <a:solidFill>
+                  <a:srgbClr val="121316"/>
+                </a:solidFill>
+                <a:latin typeface="Arial"/>
+              </a:rPr>
+              <a:t>Reaktivieren</a:t>
+            </a:r>
+          </a:p>
+          <a:p>
+            <a:pPr algn="l">
+              <a:spcAft>
+                <a:spcPts val="500"/>
+              </a:spcAft>
+            </a:pPr>
+            <a:r>
+              <a:rPr sz="1400" b="1" i="0">
+                <a:solidFill>
+                  <a:srgbClr val="71717A"/>
+                </a:solidFill>
+                <a:latin typeface="Arial"/>
+              </a:rPr>
+              <a:t>3′</a:t>
+            </a:r>
+          </a:p>
+          <a:p>
+            <a:pPr algn="l">
+              <a:lnSpc>
+                <a:spcPct val="105000"/>
+              </a:lnSpc>
+              <a:spcAft>
+                <a:spcPts val="200"/>
+              </a:spcAft>
+            </a:pPr>
+            <a:r>
+              <a:rPr sz="1200" b="0" i="0">
+                <a:solidFill>
+                  <a:srgbClr val="71717A"/>
+                </a:solidFill>
+                <a:latin typeface="Arial"/>
+              </a:rPr>
+              <a:t>An KI anknüpfen</a:t>
+            </a:r>
+          </a:p>
+        </p:txBody>
+      </p:sp>
+      <p:cxnSp>
+        <p:nvCxnSpPr>
+          <p:cNvPr id="11" name="Connector 10"/>
+          <p:cNvCxnSpPr/>
+          <p:nvPr/>
+        </p:nvCxnSpPr>
+        <p:spPr>
+          <a:xfrm>
+            <a:off x="5056632" y="2514600"/>
+            <a:ext cx="0" cy="2743200"/>
+          </a:xfrm>
+          <a:prstGeom prst="line">
+            <a:avLst/>
+          </a:prstGeom>
+          <a:ln w="12700">
+            <a:solidFill>
+              <a:srgbClr val="E4E4E7"/>
+            </a:solidFill>
+          </a:ln>
+          <a:effectLst/>
+        </p:spPr>
+      </p:cxnSp>
+      <p:sp>
+        <p:nvSpPr>
+          <p:cNvPr id="12" name="TextBox 11"/>
+          <p:cNvSpPr txBox="1"/>
+          <p:nvPr/>
+        </p:nvSpPr>
+        <p:spPr>
+          <a:xfrm>
+            <a:off x="5166360" y="2651760"/>
+            <a:ext cx="1874519" cy="822960"/>
+          </a:xfrm>
+          <a:prstGeom prst="rect">
+            <a:avLst/>
+          </a:prstGeom>
+          <a:noFill/>
+        </p:spPr>
+        <p:txBody>
+          <a:bodyPr wrap="square" anchor="t" lIns="0" rIns="0" tIns="0" bIns="0">
+            <a:spAutoFit/>
+          </a:bodyPr>
+          <a:lstStyle/>
+          <a:p>
+            <a:pPr algn="l">
+              <a:spcAft>
+                <a:spcPts val="200"/>
+              </a:spcAft>
+            </a:pPr>
+            <a:r>
+              <a:rPr sz="3400" b="1" i="0">
+                <a:solidFill>
+                  <a:srgbClr val="121316"/>
+                </a:solidFill>
+                <a:latin typeface="Arial"/>
+              </a:rPr>
+              <a:t>I</a:t>
+            </a:r>
+          </a:p>
+        </p:txBody>
+      </p:sp>
+      <p:sp>
+        <p:nvSpPr>
+          <p:cNvPr id="13" name="TextBox 12"/>
+          <p:cNvSpPr txBox="1"/>
+          <p:nvPr/>
+        </p:nvSpPr>
+        <p:spPr>
+          <a:xfrm>
+            <a:off x="5166360" y="3520439"/>
+            <a:ext cx="1874519" cy="1645920"/>
+          </a:xfrm>
+          <a:prstGeom prst="rect">
+            <a:avLst/>
+          </a:prstGeom>
+          <a:noFill/>
+        </p:spPr>
+        <p:txBody>
+          <a:bodyPr wrap="square" anchor="t" lIns="0" rIns="0" tIns="0" bIns="0">
+            <a:spAutoFit/>
+          </a:bodyPr>
+          <a:lstStyle/>
+          <a:p>
+            <a:pPr algn="l">
+              <a:lnSpc>
+                <a:spcPct val="100000"/>
+              </a:lnSpc>
+              <a:spcAft>
+                <a:spcPts val="300"/>
+              </a:spcAft>
+            </a:pPr>
+            <a:r>
+              <a:rPr sz="1500" b="1" i="0">
+                <a:solidFill>
+                  <a:srgbClr val="121316"/>
+                </a:solidFill>
+                <a:latin typeface="Arial"/>
+              </a:rPr>
+              <a:t>Informieren</a:t>
+            </a:r>
+          </a:p>
+          <a:p>
+            <a:pPr algn="l">
+              <a:spcAft>
+                <a:spcPts val="500"/>
+              </a:spcAft>
+            </a:pPr>
+            <a:r>
+              <a:rPr sz="1400" b="1" i="0">
+                <a:solidFill>
+                  <a:srgbClr val="71717A"/>
+                </a:solidFill>
+                <a:latin typeface="Arial"/>
+              </a:rPr>
+              <a:t>5′</a:t>
+            </a:r>
+          </a:p>
+          <a:p>
+            <a:pPr algn="l">
+              <a:lnSpc>
+                <a:spcPct val="105000"/>
+              </a:lnSpc>
+              <a:spcAft>
+                <a:spcPts val="200"/>
+              </a:spcAft>
+            </a:pPr>
+            <a:r>
+              <a:rPr sz="1200" b="0" i="0">
+                <a:solidFill>
+                  <a:srgbClr val="71717A"/>
+                </a:solidFill>
+                <a:latin typeface="Arial"/>
+              </a:rPr>
+              <a:t>AI Studio + Demo</a:t>
+            </a:r>
+          </a:p>
+        </p:txBody>
+      </p:sp>
+      <p:cxnSp>
+        <p:nvCxnSpPr>
+          <p:cNvPr id="14" name="Connector 13"/>
+          <p:cNvCxnSpPr/>
+          <p:nvPr/>
+        </p:nvCxnSpPr>
+        <p:spPr>
+          <a:xfrm>
+            <a:off x="7150608" y="2514600"/>
+            <a:ext cx="0" cy="2743200"/>
+          </a:xfrm>
+          <a:prstGeom prst="line">
+            <a:avLst/>
+          </a:prstGeom>
+          <a:ln w="12700">
+            <a:solidFill>
+              <a:srgbClr val="E4E4E7"/>
+            </a:solidFill>
+          </a:ln>
+          <a:effectLst/>
+        </p:spPr>
+      </p:cxnSp>
+      <p:sp>
+        <p:nvSpPr>
+          <p:cNvPr id="15" name="TextBox 14"/>
+          <p:cNvSpPr txBox="1"/>
+          <p:nvPr/>
+        </p:nvSpPr>
+        <p:spPr>
+          <a:xfrm>
+            <a:off x="7260336" y="2651760"/>
+            <a:ext cx="1874519" cy="822960"/>
+          </a:xfrm>
+          <a:prstGeom prst="rect">
+            <a:avLst/>
+          </a:prstGeom>
+          <a:noFill/>
+        </p:spPr>
+        <p:txBody>
+          <a:bodyPr wrap="square" anchor="t" lIns="0" rIns="0" tIns="0" bIns="0">
+            <a:spAutoFit/>
+          </a:bodyPr>
+          <a:lstStyle/>
+          <a:p>
+            <a:pPr algn="l">
+              <a:spcAft>
+                <a:spcPts val="200"/>
+              </a:spcAft>
+            </a:pPr>
+            <a:r>
+              <a:rPr sz="3400" b="1" i="0">
+                <a:solidFill>
+                  <a:srgbClr val="121316"/>
+                </a:solidFill>
+                <a:latin typeface="Arial"/>
+              </a:rPr>
+              <a:t>V</a:t>
+            </a:r>
+          </a:p>
+        </p:txBody>
+      </p:sp>
+      <p:sp>
+        <p:nvSpPr>
+          <p:cNvPr id="16" name="TextBox 15"/>
+          <p:cNvSpPr txBox="1"/>
+          <p:nvPr/>
+        </p:nvSpPr>
+        <p:spPr>
+          <a:xfrm>
+            <a:off x="7260336" y="3520439"/>
+            <a:ext cx="1874519" cy="1645920"/>
+          </a:xfrm>
+          <a:prstGeom prst="rect">
+            <a:avLst/>
+          </a:prstGeom>
+          <a:noFill/>
+        </p:spPr>
+        <p:txBody>
+          <a:bodyPr wrap="square" anchor="t" lIns="0" rIns="0" tIns="0" bIns="0">
+            <a:spAutoFit/>
+          </a:bodyPr>
+          <a:lstStyle/>
+          <a:p>
+            <a:pPr algn="l">
+              <a:lnSpc>
+                <a:spcPct val="100000"/>
+              </a:lnSpc>
+              <a:spcAft>
+                <a:spcPts val="300"/>
+              </a:spcAft>
+            </a:pPr>
+            <a:r>
+              <a:rPr sz="1500" b="1" i="0">
+                <a:solidFill>
+                  <a:srgbClr val="121316"/>
+                </a:solidFill>
+                <a:latin typeface="Arial"/>
+              </a:rPr>
+              <a:t>Verarbeiten</a:t>
+            </a:r>
+          </a:p>
+          <a:p>
+            <a:pPr algn="l">
+              <a:spcAft>
+                <a:spcPts val="500"/>
+              </a:spcAft>
+            </a:pPr>
+            <a:r>
+              <a:rPr sz="1400" b="1" i="0">
+                <a:solidFill>
+                  <a:srgbClr val="71717A"/>
+                </a:solidFill>
+                <a:latin typeface="Arial"/>
+              </a:rPr>
+              <a:t>8′</a:t>
+            </a:r>
+          </a:p>
+          <a:p>
+            <a:pPr algn="l">
+              <a:lnSpc>
+                <a:spcPct val="105000"/>
+              </a:lnSpc>
+              <a:spcAft>
+                <a:spcPts val="200"/>
+              </a:spcAft>
+            </a:pPr>
+            <a:r>
+              <a:rPr sz="1200" b="0" i="0">
+                <a:solidFill>
+                  <a:srgbClr val="71717A"/>
+                </a:solidFill>
+                <a:latin typeface="Arial"/>
+              </a:rPr>
+              <a:t>Selbst bauen</a:t>
+            </a:r>
+          </a:p>
+        </p:txBody>
+      </p:sp>
+      <p:cxnSp>
+        <p:nvCxnSpPr>
+          <p:cNvPr id="17" name="Connector 16"/>
+          <p:cNvCxnSpPr/>
+          <p:nvPr/>
+        </p:nvCxnSpPr>
+        <p:spPr>
+          <a:xfrm>
+            <a:off x="9244584" y="2514600"/>
+            <a:ext cx="0" cy="2743200"/>
+          </a:xfrm>
+          <a:prstGeom prst="line">
+            <a:avLst/>
+          </a:prstGeom>
+          <a:ln w="12700">
+            <a:solidFill>
+              <a:srgbClr val="E4E4E7"/>
+            </a:solidFill>
+          </a:ln>
+          <a:effectLst/>
+        </p:spPr>
+      </p:cxnSp>
+      <p:sp>
+        <p:nvSpPr>
+          <p:cNvPr id="18" name="TextBox 17"/>
+          <p:cNvSpPr txBox="1"/>
+          <p:nvPr/>
+        </p:nvSpPr>
+        <p:spPr>
+          <a:xfrm>
+            <a:off x="9354311" y="2651760"/>
+            <a:ext cx="1874519" cy="822960"/>
+          </a:xfrm>
+          <a:prstGeom prst="rect">
+            <a:avLst/>
+          </a:prstGeom>
+          <a:noFill/>
+        </p:spPr>
+        <p:txBody>
+          <a:bodyPr wrap="square" anchor="t" lIns="0" rIns="0" tIns="0" bIns="0">
+            <a:spAutoFit/>
+          </a:bodyPr>
+          <a:lstStyle/>
+          <a:p>
+            <a:pPr algn="l">
+              <a:spcAft>
+                <a:spcPts val="200"/>
+              </a:spcAft>
+            </a:pPr>
+            <a:r>
+              <a:rPr sz="3400" b="1" i="0">
+                <a:solidFill>
+                  <a:srgbClr val="121316"/>
+                </a:solidFill>
+                <a:latin typeface="Arial"/>
+              </a:rPr>
+              <a:t>A</a:t>
+            </a:r>
+          </a:p>
+        </p:txBody>
+      </p:sp>
+      <p:sp>
+        <p:nvSpPr>
+          <p:cNvPr id="19" name="TextBox 18"/>
+          <p:cNvSpPr txBox="1"/>
+          <p:nvPr/>
+        </p:nvSpPr>
+        <p:spPr>
+          <a:xfrm>
+            <a:off x="9354311" y="3520439"/>
+            <a:ext cx="1874519" cy="1645920"/>
+          </a:xfrm>
+          <a:prstGeom prst="rect">
+            <a:avLst/>
+          </a:prstGeom>
+          <a:noFill/>
+        </p:spPr>
+        <p:txBody>
+          <a:bodyPr wrap="square" anchor="t" lIns="0" rIns="0" tIns="0" bIns="0">
+            <a:spAutoFit/>
+          </a:bodyPr>
+          <a:lstStyle/>
+          <a:p>
+            <a:pPr algn="l">
+              <a:lnSpc>
+                <a:spcPct val="100000"/>
+              </a:lnSpc>
+              <a:spcAft>
+                <a:spcPts val="300"/>
+              </a:spcAft>
+            </a:pPr>
+            <a:r>
+              <a:rPr sz="1500" b="1" i="0">
+                <a:solidFill>
+                  <a:srgbClr val="121316"/>
+                </a:solidFill>
+                <a:latin typeface="Arial"/>
+              </a:rPr>
+              <a:t>Auswerten</a:t>
+            </a:r>
+          </a:p>
+          <a:p>
+            <a:pPr algn="l">
+              <a:spcAft>
+                <a:spcPts val="500"/>
+              </a:spcAft>
+            </a:pPr>
+            <a:r>
+              <a:rPr sz="1400" b="1" i="0">
+                <a:solidFill>
+                  <a:srgbClr val="71717A"/>
+                </a:solidFill>
+                <a:latin typeface="Arial"/>
+              </a:rPr>
+              <a:t>4′</a:t>
+            </a:r>
+          </a:p>
+          <a:p>
+            <a:pPr algn="l">
+              <a:lnSpc>
+                <a:spcPct val="105000"/>
+              </a:lnSpc>
+              <a:spcAft>
+                <a:spcPts val="200"/>
+              </a:spcAft>
+            </a:pPr>
+            <a:r>
+              <a:rPr sz="1200" b="0" i="0">
+                <a:solidFill>
+                  <a:srgbClr val="71717A"/>
+                </a:solidFill>
+                <a:latin typeface="Arial"/>
+              </a:rPr>
+              <a:t>Prüfen &amp; Abschluss</a:t>
+            </a:r>
+          </a:p>
+        </p:txBody>
+      </p:sp>
+      <p:cxnSp>
+        <p:nvCxnSpPr>
+          <p:cNvPr id="20" name="Connector 19"/>
+          <p:cNvCxnSpPr/>
+          <p:nvPr/>
+        </p:nvCxnSpPr>
+        <p:spPr>
+          <a:xfrm>
+            <a:off x="868680" y="5349240"/>
+            <a:ext cx="10469879" cy="0"/>
+          </a:xfrm>
+          <a:prstGeom prst="line">
+            <a:avLst/>
+          </a:prstGeom>
+          <a:ln w="12700">
+            <a:solidFill>
+              <a:srgbClr val="E4E4E7"/>
+            </a:solidFill>
+          </a:ln>
+          <a:effectLst/>
+        </p:spPr>
+      </p:cxnSp>
+      <p:sp>
+        <p:nvSpPr>
+          <p:cNvPr id="21" name="TextBox 20"/>
+          <p:cNvSpPr txBox="1"/>
+          <p:nvPr/>
+        </p:nvSpPr>
+        <p:spPr>
+          <a:xfrm>
+            <a:off x="868680" y="5532120"/>
+            <a:ext cx="10469880" cy="365760"/>
+          </a:xfrm>
+          <a:prstGeom prst="rect">
+            <a:avLst/>
+          </a:prstGeom>
+          <a:noFill/>
+        </p:spPr>
+        <p:txBody>
+          <a:bodyPr wrap="square" anchor="t" lIns="0" rIns="0" tIns="0" bIns="0">
+            <a:spAutoFit/>
+          </a:bodyPr>
+          <a:lstStyle/>
+          <a:p>
+            <a:pPr algn="l">
+              <a:spcAft>
+                <a:spcPts val="200"/>
+              </a:spcAft>
+            </a:pPr>
+            <a:r>
+              <a:rPr sz="1300" b="0" i="1">
+                <a:solidFill>
+                  <a:srgbClr val="71717A"/>
+                </a:solidFill>
+                <a:latin typeface="Arial"/>
+              </a:rPr>
+              <a:t>Gesamt 23 Minuten — Schwerpunkt: selbst ausprobieren.</a:t>
             </a:r>
           </a:p>
         </p:txBody>
@@ -5158,7 +5792,7 @@
                 </a:solidFill>
                 <a:latin typeface="Arial"/>
               </a:rPr>
-              <a:t>ABLAUF · ARIVA</a:t>
+              <a:t>LERNZIELE · NACH MAGER</a:t>
             </a:r>
           </a:p>
         </p:txBody>
@@ -5197,7 +5831,7 @@
                 </a:solidFill>
                 <a:latin typeface="Arial"/>
               </a:rPr>
-              <a:t>So läuft die Lektion</a:t>
+              <a:t>Was ihr danach könnt</a:t>
             </a:r>
           </a:p>
         </p:txBody>
@@ -5210,7 +5844,7 @@
         </p:nvCxnSpPr>
         <p:spPr>
           <a:xfrm>
-            <a:off x="868680" y="2331720"/>
+            <a:off x="868680" y="2468880"/>
             <a:ext cx="10469879" cy="0"/>
           </a:xfrm>
           <a:prstGeom prst="line">
@@ -5226,14 +5860,83 @@
       </p:cxnSp>
       <p:sp>
         <p:nvSpPr>
-          <p:cNvPr id="6" name="TextBox 5"/>
+          <p:cNvPr id="6" name="Oval 5"/>
+          <p:cNvSpPr/>
+          <p:nvPr/>
+        </p:nvSpPr>
+        <p:spPr>
+          <a:xfrm>
+            <a:off x="868680" y="2761488"/>
+            <a:ext cx="548640" cy="548640"/>
+          </a:xfrm>
+          <a:prstGeom prst="ellipse">
+            <a:avLst/>
+          </a:prstGeom>
+          <a:noFill/>
+          <a:ln w="16510">
+            <a:solidFill>
+              <a:srgbClr val="121316"/>
+            </a:solidFill>
+          </a:ln>
+          <a:effectLst/>
+        </p:spPr>
+        <p:txBody>
+          <a:bodyPr rtlCol="0" anchor="ctr"/>
+          <a:lstStyle/>
+          <a:p>
+            <a:pPr algn="ctr"/>
+          </a:p>
+        </p:txBody>
+      </p:sp>
+      <p:sp>
+        <p:nvSpPr>
+          <p:cNvPr id="7" name="TextBox 6"/>
           <p:cNvSpPr txBox="1"/>
           <p:nvPr/>
         </p:nvSpPr>
         <p:spPr>
           <a:xfrm>
-            <a:off x="978407" y="2651760"/>
-            <a:ext cx="1874519" cy="822960"/>
+            <a:off x="868680" y="2734056"/>
+            <a:ext cx="548640" cy="548640"/>
+          </a:xfrm>
+          <a:prstGeom prst="rect">
+            <a:avLst/>
+          </a:prstGeom>
+          <a:noFill/>
+        </p:spPr>
+        <p:txBody>
+          <a:bodyPr wrap="square" anchor="ctr" lIns="0" rIns="0" tIns="0" bIns="0">
+            <a:spAutoFit/>
+          </a:bodyPr>
+          <a:lstStyle/>
+          <a:p>
+            <a:pPr algn="ctr">
+              <a:spcAft>
+                <a:spcPts val="200"/>
+              </a:spcAft>
+            </a:pPr>
+            <a:r>
+              <a:rPr sz="1400" b="1" i="0">
+                <a:solidFill>
+                  <a:srgbClr val="121316"/>
+                </a:solidFill>
+                <a:latin typeface="Arial"/>
+              </a:rPr>
+              <a:t>1</a:t>
+            </a:r>
+          </a:p>
+        </p:txBody>
+      </p:sp>
+      <p:sp>
+        <p:nvSpPr>
+          <p:cNvPr id="8" name="TextBox 7"/>
+          <p:cNvSpPr txBox="1"/>
+          <p:nvPr/>
+        </p:nvSpPr>
+        <p:spPr>
+          <a:xfrm>
+            <a:off x="1737360" y="2724912"/>
+            <a:ext cx="9509760" cy="1005840"/>
           </a:xfrm>
           <a:prstGeom prst="rect">
             <a:avLst/>
@@ -5248,108 +5951,47 @@
           <a:p>
             <a:pPr algn="l">
               <a:spcAft>
+                <a:spcPts val="300"/>
+              </a:spcAft>
+            </a:pPr>
+            <a:r>
+              <a:rPr sz="2000" b="1" i="0">
+                <a:solidFill>
+                  <a:srgbClr val="121316"/>
+                </a:solidFill>
+                <a:latin typeface="Arial"/>
+              </a:rPr>
+              <a:t>Erklären, was Google AI Studio ist</a:t>
+            </a:r>
+          </a:p>
+          <a:p>
+            <a:pPr algn="l">
+              <a:spcAft>
                 <a:spcPts val="200"/>
               </a:spcAft>
             </a:pPr>
             <a:r>
-              <a:rPr sz="3400" b="1" i="0">
-                <a:solidFill>
-                  <a:srgbClr val="121316"/>
-                </a:solidFill>
-                <a:latin typeface="Arial"/>
-              </a:rPr>
-              <a:t>A</a:t>
-            </a:r>
-          </a:p>
-        </p:txBody>
-      </p:sp>
-      <p:sp>
-        <p:nvSpPr>
-          <p:cNvPr id="7" name="TextBox 6"/>
-          <p:cNvSpPr txBox="1"/>
-          <p:nvPr/>
-        </p:nvSpPr>
-        <p:spPr>
-          <a:xfrm>
-            <a:off x="978407" y="3520439"/>
-            <a:ext cx="1874519" cy="1645920"/>
-          </a:xfrm>
-          <a:prstGeom prst="rect">
-            <a:avLst/>
-          </a:prstGeom>
-          <a:noFill/>
-        </p:spPr>
-        <p:txBody>
-          <a:bodyPr wrap="square" anchor="t" lIns="0" rIns="0" tIns="0" bIns="0">
-            <a:spAutoFit/>
-          </a:bodyPr>
-          <a:lstStyle/>
-          <a:p>
-            <a:pPr algn="l">
-              <a:lnSpc>
-                <a:spcPct val="100000"/>
-              </a:lnSpc>
-              <a:spcAft>
-                <a:spcPts val="300"/>
-              </a:spcAft>
-            </a:pPr>
-            <a:r>
-              <a:rPr sz="1500" b="1" i="0">
-                <a:solidFill>
-                  <a:srgbClr val="121316"/>
-                </a:solidFill>
-                <a:latin typeface="Arial"/>
-              </a:rPr>
-              <a:t>Ausrichten</a:t>
-            </a:r>
-          </a:p>
-          <a:p>
-            <a:pPr algn="l">
-              <a:spcAft>
-                <a:spcPts val="500"/>
-              </a:spcAft>
-            </a:pPr>
-            <a:r>
-              <a:rPr sz="1400" b="1" i="0">
+              <a:rPr sz="1400" b="0" i="0">
                 <a:solidFill>
                   <a:srgbClr val="71717A"/>
                 </a:solidFill>
                 <a:latin typeface="Arial"/>
               </a:rPr>
-              <a:t>3′</a:t>
-            </a:r>
-          </a:p>
-          <a:p>
-            <a:pPr algn="l">
-              <a:lnSpc>
-                <a:spcPct val="105000"/>
-              </a:lnSpc>
-              <a:spcAft>
-                <a:spcPts val="200"/>
-              </a:spcAft>
-            </a:pPr>
-            <a:r>
-              <a:rPr sz="1200" b="0" i="0">
-                <a:solidFill>
-                  <a:srgbClr val="71717A"/>
-                </a:solidFill>
-                <a:latin typeface="Arial"/>
-              </a:rPr>
-              <a:t>Ziele &amp; Ablauf</a:t>
+              <a:t>Zwei Beispiele nennen, was man damit bauen kann.</a:t>
             </a:r>
           </a:p>
         </p:txBody>
       </p:sp>
       <p:cxnSp>
         <p:nvCxnSpPr>
-          <p:cNvPr id="8" name="Connector 7"/>
+          <p:cNvPr id="9" name="Connector 8"/>
           <p:cNvCxnSpPr/>
           <p:nvPr/>
         </p:nvCxnSpPr>
         <p:spPr>
           <a:xfrm>
-            <a:off x="2962656" y="2514600"/>
-            <a:ext cx="0" cy="2743200"/>
+            <a:off x="868680" y="3749039"/>
+            <a:ext cx="10469879" cy="0"/>
           </a:xfrm>
           <a:prstGeom prst="line">
             <a:avLst/>
@@ -5364,14 +6006,83 @@
       </p:cxnSp>
       <p:sp>
         <p:nvSpPr>
-          <p:cNvPr id="9" name="TextBox 8"/>
+          <p:cNvPr id="10" name="Oval 9"/>
+          <p:cNvSpPr/>
+          <p:nvPr/>
+        </p:nvSpPr>
+        <p:spPr>
+          <a:xfrm>
+            <a:off x="868680" y="4041648"/>
+            <a:ext cx="548640" cy="548640"/>
+          </a:xfrm>
+          <a:prstGeom prst="ellipse">
+            <a:avLst/>
+          </a:prstGeom>
+          <a:noFill/>
+          <a:ln w="16510">
+            <a:solidFill>
+              <a:srgbClr val="121316"/>
+            </a:solidFill>
+          </a:ln>
+          <a:effectLst/>
+        </p:spPr>
+        <p:txBody>
+          <a:bodyPr rtlCol="0" anchor="ctr"/>
+          <a:lstStyle/>
+          <a:p>
+            <a:pPr algn="ctr"/>
+          </a:p>
+        </p:txBody>
+      </p:sp>
+      <p:sp>
+        <p:nvSpPr>
+          <p:cNvPr id="11" name="TextBox 10"/>
           <p:cNvSpPr txBox="1"/>
           <p:nvPr/>
         </p:nvSpPr>
         <p:spPr>
           <a:xfrm>
-            <a:off x="3072384" y="2651760"/>
-            <a:ext cx="1874519" cy="822960"/>
+            <a:off x="868680" y="4014215"/>
+            <a:ext cx="548640" cy="548640"/>
+          </a:xfrm>
+          <a:prstGeom prst="rect">
+            <a:avLst/>
+          </a:prstGeom>
+          <a:noFill/>
+        </p:spPr>
+        <p:txBody>
+          <a:bodyPr wrap="square" anchor="ctr" lIns="0" rIns="0" tIns="0" bIns="0">
+            <a:spAutoFit/>
+          </a:bodyPr>
+          <a:lstStyle/>
+          <a:p>
+            <a:pPr algn="ctr">
+              <a:spcAft>
+                <a:spcPts val="200"/>
+              </a:spcAft>
+            </a:pPr>
+            <a:r>
+              <a:rPr sz="1400" b="1" i="0">
+                <a:solidFill>
+                  <a:srgbClr val="121316"/>
+                </a:solidFill>
+                <a:latin typeface="Arial"/>
+              </a:rPr>
+              <a:t>2</a:t>
+            </a:r>
+          </a:p>
+        </p:txBody>
+      </p:sp>
+      <p:sp>
+        <p:nvSpPr>
+          <p:cNvPr id="12" name="TextBox 11"/>
+          <p:cNvSpPr txBox="1"/>
+          <p:nvPr/>
+        </p:nvSpPr>
+        <p:spPr>
+          <a:xfrm>
+            <a:off x="1737360" y="4005072"/>
+            <a:ext cx="9509760" cy="1005840"/>
           </a:xfrm>
           <a:prstGeom prst="rect">
             <a:avLst/>
@@ -5386,108 +6097,47 @@
           <a:p>
             <a:pPr algn="l">
               <a:spcAft>
+                <a:spcPts val="300"/>
+              </a:spcAft>
+            </a:pPr>
+            <a:r>
+              <a:rPr sz="2000" b="1" i="0">
+                <a:solidFill>
+                  <a:srgbClr val="121316"/>
+                </a:solidFill>
+                <a:latin typeface="Arial"/>
+              </a:rPr>
+              <a:t>Einen Website-Auftrag bauen</a:t>
+            </a:r>
+          </a:p>
+          <a:p>
+            <a:pPr algn="l">
+              <a:spcAft>
                 <a:spcPts val="200"/>
               </a:spcAft>
             </a:pPr>
             <a:r>
-              <a:rPr sz="3400" b="1" i="0">
-                <a:solidFill>
-                  <a:srgbClr val="121316"/>
-                </a:solidFill>
-                <a:latin typeface="Arial"/>
-              </a:rPr>
-              <a:t>R</a:t>
-            </a:r>
-          </a:p>
-        </p:txBody>
-      </p:sp>
-      <p:sp>
-        <p:nvSpPr>
-          <p:cNvPr id="10" name="TextBox 9"/>
-          <p:cNvSpPr txBox="1"/>
-          <p:nvPr/>
-        </p:nvSpPr>
-        <p:spPr>
-          <a:xfrm>
-            <a:off x="3072384" y="3520439"/>
-            <a:ext cx="1874519" cy="1645920"/>
-          </a:xfrm>
-          <a:prstGeom prst="rect">
-            <a:avLst/>
-          </a:prstGeom>
-          <a:noFill/>
-        </p:spPr>
-        <p:txBody>
-          <a:bodyPr wrap="square" anchor="t" lIns="0" rIns="0" tIns="0" bIns="0">
-            <a:spAutoFit/>
-          </a:bodyPr>
-          <a:lstStyle/>
-          <a:p>
-            <a:pPr algn="l">
-              <a:lnSpc>
-                <a:spcPct val="100000"/>
-              </a:lnSpc>
-              <a:spcAft>
-                <a:spcPts val="300"/>
-              </a:spcAft>
-            </a:pPr>
-            <a:r>
-              <a:rPr sz="1500" b="1" i="0">
-                <a:solidFill>
-                  <a:srgbClr val="121316"/>
-                </a:solidFill>
-                <a:latin typeface="Arial"/>
-              </a:rPr>
-              <a:t>Reaktivieren</a:t>
-            </a:r>
-          </a:p>
-          <a:p>
-            <a:pPr algn="l">
-              <a:spcAft>
-                <a:spcPts val="500"/>
-              </a:spcAft>
-            </a:pPr>
-            <a:r>
-              <a:rPr sz="1400" b="1" i="0">
+              <a:rPr sz="1400" b="0" i="0">
                 <a:solidFill>
                   <a:srgbClr val="71717A"/>
                 </a:solidFill>
                 <a:latin typeface="Arial"/>
               </a:rPr>
-              <a:t>3′</a:t>
-            </a:r>
-          </a:p>
-          <a:p>
-            <a:pPr algn="l">
-              <a:lnSpc>
-                <a:spcPct val="105000"/>
-              </a:lnSpc>
-              <a:spcAft>
-                <a:spcPts val="200"/>
-              </a:spcAft>
-            </a:pPr>
-            <a:r>
-              <a:rPr sz="1200" b="0" i="0">
-                <a:solidFill>
-                  <a:srgbClr val="71717A"/>
-                </a:solidFill>
-                <a:latin typeface="Arial"/>
-              </a:rPr>
-              <a:t>An KI anknüpfen</a:t>
+              <a:t>Mit dem Baukasten einen klaren Prompt zusammenstellen.</a:t>
             </a:r>
           </a:p>
         </p:txBody>
       </p:sp>
       <p:cxnSp>
         <p:nvCxnSpPr>
-          <p:cNvPr id="11" name="Connector 10"/>
+          <p:cNvPr id="13" name="Connector 12"/>
           <p:cNvCxnSpPr/>
           <p:nvPr/>
         </p:nvCxnSpPr>
         <p:spPr>
           <a:xfrm>
-            <a:off x="5056632" y="2514600"/>
-            <a:ext cx="0" cy="2743200"/>
+            <a:off x="868680" y="5029200"/>
+            <a:ext cx="10469879" cy="0"/>
           </a:xfrm>
           <a:prstGeom prst="line">
             <a:avLst/>
@@ -5502,14 +6152,83 @@
       </p:cxnSp>
       <p:sp>
         <p:nvSpPr>
-          <p:cNvPr id="12" name="TextBox 11"/>
+          <p:cNvPr id="14" name="Oval 13"/>
+          <p:cNvSpPr/>
+          <p:nvPr/>
+        </p:nvSpPr>
+        <p:spPr>
+          <a:xfrm>
+            <a:off x="868680" y="5321808"/>
+            <a:ext cx="548640" cy="548640"/>
+          </a:xfrm>
+          <a:prstGeom prst="ellipse">
+            <a:avLst/>
+          </a:prstGeom>
+          <a:noFill/>
+          <a:ln w="16510">
+            <a:solidFill>
+              <a:srgbClr val="121316"/>
+            </a:solidFill>
+          </a:ln>
+          <a:effectLst/>
+        </p:spPr>
+        <p:txBody>
+          <a:bodyPr rtlCol="0" anchor="ctr"/>
+          <a:lstStyle/>
+          <a:p>
+            <a:pPr algn="ctr"/>
+          </a:p>
+        </p:txBody>
+      </p:sp>
+      <p:sp>
+        <p:nvSpPr>
+          <p:cNvPr id="15" name="TextBox 14"/>
           <p:cNvSpPr txBox="1"/>
           <p:nvPr/>
         </p:nvSpPr>
         <p:spPr>
           <a:xfrm>
-            <a:off x="5166360" y="2651760"/>
-            <a:ext cx="1874519" cy="822960"/>
+            <a:off x="868680" y="5294376"/>
+            <a:ext cx="548640" cy="548640"/>
+          </a:xfrm>
+          <a:prstGeom prst="rect">
+            <a:avLst/>
+          </a:prstGeom>
+          <a:noFill/>
+        </p:spPr>
+        <p:txBody>
+          <a:bodyPr wrap="square" anchor="ctr" lIns="0" rIns="0" tIns="0" bIns="0">
+            <a:spAutoFit/>
+          </a:bodyPr>
+          <a:lstStyle/>
+          <a:p>
+            <a:pPr algn="ctr">
+              <a:spcAft>
+                <a:spcPts val="200"/>
+              </a:spcAft>
+            </a:pPr>
+            <a:r>
+              <a:rPr sz="1400" b="1" i="0">
+                <a:solidFill>
+                  <a:srgbClr val="121316"/>
+                </a:solidFill>
+                <a:latin typeface="Arial"/>
+              </a:rPr>
+              <a:t>3</a:t>
+            </a:r>
+          </a:p>
+        </p:txBody>
+      </p:sp>
+      <p:sp>
+        <p:nvSpPr>
+          <p:cNvPr id="16" name="TextBox 15"/>
+          <p:cNvSpPr txBox="1"/>
+          <p:nvPr/>
+        </p:nvSpPr>
+        <p:spPr>
+          <a:xfrm>
+            <a:off x="1737360" y="5285232"/>
+            <a:ext cx="9509760" cy="1005840"/>
           </a:xfrm>
           <a:prstGeom prst="rect">
             <a:avLst/>
@@ -5524,108 +6243,47 @@
           <a:p>
             <a:pPr algn="l">
               <a:spcAft>
+                <a:spcPts val="300"/>
+              </a:spcAft>
+            </a:pPr>
+            <a:r>
+              <a:rPr sz="2000" b="1" i="0">
+                <a:solidFill>
+                  <a:srgbClr val="121316"/>
+                </a:solidFill>
+                <a:latin typeface="Arial"/>
+              </a:rPr>
+              <a:t>Eine erste Website starten</a:t>
+            </a:r>
+          </a:p>
+          <a:p>
+            <a:pPr algn="l">
+              <a:spcAft>
                 <a:spcPts val="200"/>
               </a:spcAft>
             </a:pPr>
             <a:r>
-              <a:rPr sz="3400" b="1" i="0">
-                <a:solidFill>
-                  <a:srgbClr val="121316"/>
-                </a:solidFill>
-                <a:latin typeface="Arial"/>
-              </a:rPr>
-              <a:t>I</a:t>
-            </a:r>
-          </a:p>
-        </p:txBody>
-      </p:sp>
-      <p:sp>
-        <p:nvSpPr>
-          <p:cNvPr id="13" name="TextBox 12"/>
-          <p:cNvSpPr txBox="1"/>
-          <p:nvPr/>
-        </p:nvSpPr>
-        <p:spPr>
-          <a:xfrm>
-            <a:off x="5166360" y="3520439"/>
-            <a:ext cx="1874519" cy="1645920"/>
-          </a:xfrm>
-          <a:prstGeom prst="rect">
-            <a:avLst/>
-          </a:prstGeom>
-          <a:noFill/>
-        </p:spPr>
-        <p:txBody>
-          <a:bodyPr wrap="square" anchor="t" lIns="0" rIns="0" tIns="0" bIns="0">
-            <a:spAutoFit/>
-          </a:bodyPr>
-          <a:lstStyle/>
-          <a:p>
-            <a:pPr algn="l">
-              <a:lnSpc>
-                <a:spcPct val="100000"/>
-              </a:lnSpc>
-              <a:spcAft>
-                <a:spcPts val="300"/>
-              </a:spcAft>
-            </a:pPr>
-            <a:r>
-              <a:rPr sz="1500" b="1" i="0">
-                <a:solidFill>
-                  <a:srgbClr val="121316"/>
-                </a:solidFill>
-                <a:latin typeface="Arial"/>
-              </a:rPr>
-              <a:t>Informieren</a:t>
-            </a:r>
-          </a:p>
-          <a:p>
-            <a:pPr algn="l">
-              <a:spcAft>
-                <a:spcPts val="500"/>
-              </a:spcAft>
-            </a:pPr>
-            <a:r>
-              <a:rPr sz="1400" b="1" i="0">
+              <a:rPr sz="1400" b="0" i="0">
                 <a:solidFill>
                   <a:srgbClr val="71717A"/>
                 </a:solidFill>
                 <a:latin typeface="Arial"/>
               </a:rPr>
-              <a:t>5′</a:t>
-            </a:r>
-          </a:p>
-          <a:p>
-            <a:pPr algn="l">
-              <a:lnSpc>
-                <a:spcPct val="105000"/>
-              </a:lnSpc>
-              <a:spcAft>
-                <a:spcPts val="200"/>
-              </a:spcAft>
-            </a:pPr>
-            <a:r>
-              <a:rPr sz="1200" b="0" i="0">
-                <a:solidFill>
-                  <a:srgbClr val="71717A"/>
-                </a:solidFill>
-                <a:latin typeface="Arial"/>
-              </a:rPr>
-              <a:t>AI Studio + Demo</a:t>
+              <a:t>Prompt in AI Studio einfügen und losschicken.</a:t>
             </a:r>
           </a:p>
         </p:txBody>
       </p:sp>
       <p:cxnSp>
         <p:nvCxnSpPr>
-          <p:cNvPr id="14" name="Connector 13"/>
+          <p:cNvPr id="17" name="Connector 16"/>
           <p:cNvCxnSpPr/>
           <p:nvPr/>
         </p:nvCxnSpPr>
         <p:spPr>
           <a:xfrm>
-            <a:off x="7150608" y="2514600"/>
-            <a:ext cx="0" cy="2743200"/>
+            <a:off x="868680" y="6309360"/>
+            <a:ext cx="10469879" cy="0"/>
           </a:xfrm>
           <a:prstGeom prst="line">
             <a:avLst/>
@@ -5638,321 +6296,6 @@
           <a:effectLst/>
         </p:spPr>
       </p:cxnSp>
-      <p:sp>
-        <p:nvSpPr>
-          <p:cNvPr id="15" name="TextBox 14"/>
-          <p:cNvSpPr txBox="1"/>
-          <p:nvPr/>
-        </p:nvSpPr>
-        <p:spPr>
-          <a:xfrm>
-            <a:off x="7260336" y="2651760"/>
-            <a:ext cx="1874519" cy="822960"/>
-          </a:xfrm>
-          <a:prstGeom prst="rect">
-            <a:avLst/>
-          </a:prstGeom>
-          <a:noFill/>
-        </p:spPr>
-        <p:txBody>
-          <a:bodyPr wrap="square" anchor="t" lIns="0" rIns="0" tIns="0" bIns="0">
-            <a:spAutoFit/>
-          </a:bodyPr>
-          <a:lstStyle/>
-          <a:p>
-            <a:pPr algn="l">
-              <a:spcAft>
-                <a:spcPts val="200"/>
-              </a:spcAft>
-            </a:pPr>
-            <a:r>
-              <a:rPr sz="3400" b="1" i="0">
-                <a:solidFill>
-                  <a:srgbClr val="121316"/>
-                </a:solidFill>
-                <a:latin typeface="Arial"/>
-              </a:rPr>
-              <a:t>V</a:t>
-            </a:r>
-          </a:p>
-        </p:txBody>
-      </p:sp>
-      <p:sp>
-        <p:nvSpPr>
-          <p:cNvPr id="16" name="TextBox 15"/>
-          <p:cNvSpPr txBox="1"/>
-          <p:nvPr/>
-        </p:nvSpPr>
-        <p:spPr>
-          <a:xfrm>
-            <a:off x="7260336" y="3520439"/>
-            <a:ext cx="1874519" cy="1645920"/>
-          </a:xfrm>
-          <a:prstGeom prst="rect">
-            <a:avLst/>
-          </a:prstGeom>
-          <a:noFill/>
-        </p:spPr>
-        <p:txBody>
-          <a:bodyPr wrap="square" anchor="t" lIns="0" rIns="0" tIns="0" bIns="0">
-            <a:spAutoFit/>
-          </a:bodyPr>
-          <a:lstStyle/>
-          <a:p>
-            <a:pPr algn="l">
-              <a:lnSpc>
-                <a:spcPct val="100000"/>
-              </a:lnSpc>
-              <a:spcAft>
-                <a:spcPts val="300"/>
-              </a:spcAft>
-            </a:pPr>
-            <a:r>
-              <a:rPr sz="1500" b="1" i="0">
-                <a:solidFill>
-                  <a:srgbClr val="121316"/>
-                </a:solidFill>
-                <a:latin typeface="Arial"/>
-              </a:rPr>
-              <a:t>Verarbeiten</a:t>
-            </a:r>
-          </a:p>
-          <a:p>
-            <a:pPr algn="l">
-              <a:spcAft>
-                <a:spcPts val="500"/>
-              </a:spcAft>
-            </a:pPr>
-            <a:r>
-              <a:rPr sz="1400" b="1" i="0">
-                <a:solidFill>
-                  <a:srgbClr val="71717A"/>
-                </a:solidFill>
-                <a:latin typeface="Arial"/>
-              </a:rPr>
-              <a:t>8′</a:t>
-            </a:r>
-          </a:p>
-          <a:p>
-            <a:pPr algn="l">
-              <a:lnSpc>
-                <a:spcPct val="105000"/>
-              </a:lnSpc>
-              <a:spcAft>
-                <a:spcPts val="200"/>
-              </a:spcAft>
-            </a:pPr>
-            <a:r>
-              <a:rPr sz="1200" b="0" i="0">
-                <a:solidFill>
-                  <a:srgbClr val="71717A"/>
-                </a:solidFill>
-                <a:latin typeface="Arial"/>
-              </a:rPr>
-              <a:t>Selbst bauen</a:t>
-            </a:r>
-          </a:p>
-        </p:txBody>
-      </p:sp>
-      <p:cxnSp>
-        <p:nvCxnSpPr>
-          <p:cNvPr id="17" name="Connector 16"/>
-          <p:cNvCxnSpPr/>
-          <p:nvPr/>
-        </p:nvCxnSpPr>
-        <p:spPr>
-          <a:xfrm>
-            <a:off x="9244584" y="2514600"/>
-            <a:ext cx="0" cy="2743200"/>
-          </a:xfrm>
-          <a:prstGeom prst="line">
-            <a:avLst/>
-          </a:prstGeom>
-          <a:ln w="12700">
-            <a:solidFill>
-              <a:srgbClr val="E4E4E7"/>
-            </a:solidFill>
-          </a:ln>
-          <a:effectLst/>
-        </p:spPr>
-      </p:cxnSp>
-      <p:sp>
-        <p:nvSpPr>
-          <p:cNvPr id="18" name="TextBox 17"/>
-          <p:cNvSpPr txBox="1"/>
-          <p:nvPr/>
-        </p:nvSpPr>
-        <p:spPr>
-          <a:xfrm>
-            <a:off x="9354311" y="2651760"/>
-            <a:ext cx="1874519" cy="822960"/>
-          </a:xfrm>
-          <a:prstGeom prst="rect">
-            <a:avLst/>
-          </a:prstGeom>
-          <a:noFill/>
-        </p:spPr>
-        <p:txBody>
-          <a:bodyPr wrap="square" anchor="t" lIns="0" rIns="0" tIns="0" bIns="0">
-            <a:spAutoFit/>
-          </a:bodyPr>
-          <a:lstStyle/>
-          <a:p>
-            <a:pPr algn="l">
-              <a:spcAft>
-                <a:spcPts val="200"/>
-              </a:spcAft>
-            </a:pPr>
-            <a:r>
-              <a:rPr sz="3400" b="1" i="0">
-                <a:solidFill>
-                  <a:srgbClr val="121316"/>
-                </a:solidFill>
-                <a:latin typeface="Arial"/>
-              </a:rPr>
-              <a:t>A</a:t>
-            </a:r>
-          </a:p>
-        </p:txBody>
-      </p:sp>
-      <p:sp>
-        <p:nvSpPr>
-          <p:cNvPr id="19" name="TextBox 18"/>
-          <p:cNvSpPr txBox="1"/>
-          <p:nvPr/>
-        </p:nvSpPr>
-        <p:spPr>
-          <a:xfrm>
-            <a:off x="9354311" y="3520439"/>
-            <a:ext cx="1874519" cy="1645920"/>
-          </a:xfrm>
-          <a:prstGeom prst="rect">
-            <a:avLst/>
-          </a:prstGeom>
-          <a:noFill/>
-        </p:spPr>
-        <p:txBody>
-          <a:bodyPr wrap="square" anchor="t" lIns="0" rIns="0" tIns="0" bIns="0">
-            <a:spAutoFit/>
-          </a:bodyPr>
-          <a:lstStyle/>
-          <a:p>
-            <a:pPr algn="l">
-              <a:lnSpc>
-                <a:spcPct val="100000"/>
-              </a:lnSpc>
-              <a:spcAft>
-                <a:spcPts val="300"/>
-              </a:spcAft>
-            </a:pPr>
-            <a:r>
-              <a:rPr sz="1500" b="1" i="0">
-                <a:solidFill>
-                  <a:srgbClr val="121316"/>
-                </a:solidFill>
-                <a:latin typeface="Arial"/>
-              </a:rPr>
-              <a:t>Auswerten</a:t>
-            </a:r>
-          </a:p>
-          <a:p>
-            <a:pPr algn="l">
-              <a:spcAft>
-                <a:spcPts val="500"/>
-              </a:spcAft>
-            </a:pPr>
-            <a:r>
-              <a:rPr sz="1400" b="1" i="0">
-                <a:solidFill>
-                  <a:srgbClr val="71717A"/>
-                </a:solidFill>
-                <a:latin typeface="Arial"/>
-              </a:rPr>
-              <a:t>4′</a:t>
-            </a:r>
-          </a:p>
-          <a:p>
-            <a:pPr algn="l">
-              <a:lnSpc>
-                <a:spcPct val="105000"/>
-              </a:lnSpc>
-              <a:spcAft>
-                <a:spcPts val="200"/>
-              </a:spcAft>
-            </a:pPr>
-            <a:r>
-              <a:rPr sz="1200" b="0" i="0">
-                <a:solidFill>
-                  <a:srgbClr val="71717A"/>
-                </a:solidFill>
-                <a:latin typeface="Arial"/>
-              </a:rPr>
-              <a:t>Prüfen &amp; Abschluss</a:t>
-            </a:r>
-          </a:p>
-        </p:txBody>
-      </p:sp>
-      <p:cxnSp>
-        <p:nvCxnSpPr>
-          <p:cNvPr id="20" name="Connector 19"/>
-          <p:cNvCxnSpPr/>
-          <p:nvPr/>
-        </p:nvCxnSpPr>
-        <p:spPr>
-          <a:xfrm>
-            <a:off x="868680" y="5349240"/>
-            <a:ext cx="10469879" cy="0"/>
-          </a:xfrm>
-          <a:prstGeom prst="line">
-            <a:avLst/>
-          </a:prstGeom>
-          <a:ln w="12700">
-            <a:solidFill>
-              <a:srgbClr val="E4E4E7"/>
-            </a:solidFill>
-          </a:ln>
-          <a:effectLst/>
-        </p:spPr>
-      </p:cxnSp>
-      <p:sp>
-        <p:nvSpPr>
-          <p:cNvPr id="21" name="TextBox 20"/>
-          <p:cNvSpPr txBox="1"/>
-          <p:nvPr/>
-        </p:nvSpPr>
-        <p:spPr>
-          <a:xfrm>
-            <a:off x="868680" y="5532120"/>
-            <a:ext cx="10469880" cy="365760"/>
-          </a:xfrm>
-          <a:prstGeom prst="rect">
-            <a:avLst/>
-          </a:prstGeom>
-          <a:noFill/>
-        </p:spPr>
-        <p:txBody>
-          <a:bodyPr wrap="square" anchor="t" lIns="0" rIns="0" tIns="0" bIns="0">
-            <a:spAutoFit/>
-          </a:bodyPr>
-          <a:lstStyle/>
-          <a:p>
-            <a:pPr algn="l">
-              <a:spcAft>
-                <a:spcPts val="200"/>
-              </a:spcAft>
-            </a:pPr>
-            <a:r>
-              <a:rPr sz="1300" b="0" i="1">
-                <a:solidFill>
-                  <a:srgbClr val="71717A"/>
-                </a:solidFill>
-                <a:latin typeface="Arial"/>
-              </a:rPr>
-              <a:t>Gesamt 23 Minuten — Schwerpunkt: selbst ausprobieren.</a:t>
-            </a:r>
-          </a:p>
-        </p:txBody>
-      </p:sp>
     </p:spTree>
   </p:cSld>
   <p:clrMapOvr>
@@ -5986,7 +6329,7 @@
             <a:avLst/>
           </a:prstGeom>
           <a:solidFill>
-            <a:srgbClr val="FFFFFF"/>
+            <a:srgbClr val="121316"/>
           </a:solidFill>
           <a:ln>
             <a:noFill/>
@@ -6009,7 +6352,7 @@
         </p:nvSpPr>
         <p:spPr>
           <a:xfrm>
-            <a:off x="868680" y="777240"/>
+            <a:off x="868680" y="868680"/>
             <a:ext cx="10058400" cy="365760"/>
           </a:xfrm>
           <a:prstGeom prst="rect">
@@ -6031,11 +6374,11 @@
             <a:r>
               <a:rPr sz="1200" b="1" i="0">
                 <a:solidFill>
-                  <a:srgbClr val="71717A"/>
-                </a:solidFill>
-                <a:latin typeface="Arial"/>
-              </a:rPr>
-              <a:t>LERNZIELE · NACH MAGER</a:t>
+                  <a:srgbClr val="A1A1AA"/>
+                </a:solidFill>
+                <a:latin typeface="Arial"/>
+              </a:rPr>
+              <a:t>REAKTIVIEREN</a:t>
             </a:r>
           </a:p>
         </p:txBody>
@@ -6048,8 +6391,8 @@
         </p:nvSpPr>
         <p:spPr>
           <a:xfrm>
-            <a:off x="868680" y="1234440"/>
-            <a:ext cx="10424160" cy="822960"/>
+            <a:off x="868680" y="1508760"/>
+            <a:ext cx="10424160" cy="1737360"/>
           </a:xfrm>
           <a:prstGeom prst="rect">
             <a:avLst/>
@@ -6063,31 +6406,92 @@
           <a:lstStyle/>
           <a:p>
             <a:pPr algn="l">
+              <a:lnSpc>
+                <a:spcPct val="106000"/>
+              </a:lnSpc>
               <a:spcAft>
                 <a:spcPts val="200"/>
               </a:spcAft>
             </a:pPr>
             <a:r>
-              <a:rPr sz="3300" b="1" i="0">
-                <a:solidFill>
-                  <a:srgbClr val="121316"/>
-                </a:solidFill>
-                <a:latin typeface="Arial"/>
-              </a:rPr>
-              <a:t>Was ihr danach könnt</a:t>
+              <a:rPr sz="3500" b="1" i="0">
+                <a:solidFill>
+                  <a:srgbClr val="FFFFFF"/>
+                </a:solidFill>
+                <a:latin typeface="Arial"/>
+              </a:rPr>
+              <a:t>Hand hoch: Wer hat schon mal</a:t>
+            </a:r>
+          </a:p>
+          <a:p>
+            <a:pPr algn="l">
+              <a:lnSpc>
+                <a:spcPct val="106000"/>
+              </a:lnSpc>
+              <a:spcAft>
+                <a:spcPts val="200"/>
+              </a:spcAft>
+            </a:pPr>
+            <a:r>
+              <a:rPr sz="3500" b="1" i="0">
+                <a:solidFill>
+                  <a:srgbClr val="FFFFFF"/>
+                </a:solidFill>
+                <a:latin typeface="Arial"/>
+              </a:rPr>
+              <a:t>eine KI etwas gefragt?</a:t>
+            </a:r>
+          </a:p>
+        </p:txBody>
+      </p:sp>
+      <p:sp>
+        <p:nvSpPr>
+          <p:cNvPr id="5" name="TextBox 4"/>
+          <p:cNvSpPr txBox="1"/>
+          <p:nvPr/>
+        </p:nvSpPr>
+        <p:spPr>
+          <a:xfrm>
+            <a:off x="868680" y="3154680"/>
+            <a:ext cx="10058400" cy="457200"/>
+          </a:xfrm>
+          <a:prstGeom prst="rect">
+            <a:avLst/>
+          </a:prstGeom>
+          <a:noFill/>
+        </p:spPr>
+        <p:txBody>
+          <a:bodyPr wrap="square" anchor="t" lIns="0" rIns="0" tIns="0" bIns="0">
+            <a:spAutoFit/>
+          </a:bodyPr>
+          <a:lstStyle/>
+          <a:p>
+            <a:pPr algn="l">
+              <a:spcAft>
+                <a:spcPts val="200"/>
+              </a:spcAft>
+            </a:pPr>
+            <a:r>
+              <a:rPr sz="1700" b="0" i="0">
+                <a:solidFill>
+                  <a:srgbClr val="A1A1AA"/>
+                </a:solidFill>
+                <a:latin typeface="Arial"/>
+              </a:rPr>
+              <a:t>ChatGPT, Gemini und Co.</a:t>
             </a:r>
           </a:p>
         </p:txBody>
       </p:sp>
       <p:cxnSp>
         <p:nvCxnSpPr>
-          <p:cNvPr id="5" name="Connector 4"/>
+          <p:cNvPr id="6" name="Connector 5"/>
           <p:cNvCxnSpPr/>
           <p:nvPr/>
         </p:nvCxnSpPr>
         <p:spPr>
           <a:xfrm>
-            <a:off x="868680" y="2468880"/>
+            <a:off x="868680" y="4069080"/>
             <a:ext cx="10469879" cy="0"/>
           </a:xfrm>
           <a:prstGeom prst="line">
@@ -6095,7 +6499,7 @@
           </a:prstGeom>
           <a:ln w="12700">
             <a:solidFill>
-              <a:srgbClr val="E4E4E7"/>
+              <a:srgbClr val="3F3F46"/>
             </a:solidFill>
           </a:ln>
           <a:effectLst/>
@@ -6103,83 +6507,14 @@
       </p:cxnSp>
       <p:sp>
         <p:nvSpPr>
-          <p:cNvPr id="6" name="Oval 5"/>
-          <p:cNvSpPr/>
-          <p:nvPr/>
-        </p:nvSpPr>
-        <p:spPr>
-          <a:xfrm>
-            <a:off x="868680" y="2761488"/>
-            <a:ext cx="548640" cy="548640"/>
-          </a:xfrm>
-          <a:prstGeom prst="ellipse">
-            <a:avLst/>
-          </a:prstGeom>
-          <a:noFill/>
-          <a:ln w="16510">
-            <a:solidFill>
-              <a:srgbClr val="121316"/>
-            </a:solidFill>
-          </a:ln>
-          <a:effectLst/>
-        </p:spPr>
-        <p:txBody>
-          <a:bodyPr rtlCol="0" anchor="ctr"/>
-          <a:lstStyle/>
-          <a:p>
-            <a:pPr algn="ctr"/>
-          </a:p>
-        </p:txBody>
-      </p:sp>
-      <p:sp>
-        <p:nvSpPr>
           <p:cNvPr id="7" name="TextBox 6"/>
           <p:cNvSpPr txBox="1"/>
           <p:nvPr/>
         </p:nvSpPr>
         <p:spPr>
           <a:xfrm>
-            <a:off x="868680" y="2734056"/>
-            <a:ext cx="548640" cy="548640"/>
-          </a:xfrm>
-          <a:prstGeom prst="rect">
-            <a:avLst/>
-          </a:prstGeom>
-          <a:noFill/>
-        </p:spPr>
-        <p:txBody>
-          <a:bodyPr wrap="square" anchor="ctr" lIns="0" rIns="0" tIns="0" bIns="0">
-            <a:spAutoFit/>
-          </a:bodyPr>
-          <a:lstStyle/>
-          <a:p>
-            <a:pPr algn="ctr">
-              <a:spcAft>
-                <a:spcPts val="200"/>
-              </a:spcAft>
-            </a:pPr>
-            <a:r>
-              <a:rPr sz="1400" b="1" i="0">
-                <a:solidFill>
-                  <a:srgbClr val="121316"/>
-                </a:solidFill>
-                <a:latin typeface="Arial"/>
-              </a:rPr>
-              <a:t>1</a:t>
-            </a:r>
-          </a:p>
-        </p:txBody>
-      </p:sp>
-      <p:sp>
-        <p:nvSpPr>
-          <p:cNvPr id="8" name="TextBox 7"/>
-          <p:cNvSpPr txBox="1"/>
-          <p:nvPr/>
-        </p:nvSpPr>
-        <p:spPr>
-          <a:xfrm>
-            <a:off x="1737360" y="2724912"/>
-            <a:ext cx="9509760" cy="1005840"/>
+            <a:off x="868680" y="4389120"/>
+            <a:ext cx="10424160" cy="1280160"/>
           </a:xfrm>
           <a:prstGeom prst="rect">
             <a:avLst/>
@@ -6193,352 +6528,34 @@
           <a:lstStyle/>
           <a:p>
             <a:pPr algn="l">
-              <a:spcAft>
-                <a:spcPts val="300"/>
-              </a:spcAft>
-            </a:pPr>
-            <a:r>
-              <a:rPr sz="2000" b="1" i="0">
-                <a:solidFill>
-                  <a:srgbClr val="121316"/>
-                </a:solidFill>
-                <a:latin typeface="Arial"/>
-              </a:rPr>
-              <a:t>Erklären, was Google AI Studio ist</a:t>
-            </a:r>
-          </a:p>
-          <a:p>
-            <a:pPr algn="l">
+              <a:lnSpc>
+                <a:spcPct val="110000"/>
+              </a:lnSpc>
               <a:spcAft>
                 <a:spcPts val="200"/>
               </a:spcAft>
             </a:pPr>
             <a:r>
-              <a:rPr sz="1400" b="0" i="0">
-                <a:solidFill>
-                  <a:srgbClr val="71717A"/>
-                </a:solidFill>
-                <a:latin typeface="Arial"/>
-              </a:rPr>
-              <a:t>Zwei Beispiele nennen, was man damit bauen kann.</a:t>
-            </a:r>
-          </a:p>
-        </p:txBody>
-      </p:sp>
-      <p:cxnSp>
-        <p:nvCxnSpPr>
-          <p:cNvPr id="9" name="Connector 8"/>
-          <p:cNvCxnSpPr/>
-          <p:nvPr/>
-        </p:nvCxnSpPr>
-        <p:spPr>
-          <a:xfrm>
-            <a:off x="868680" y="3749039"/>
-            <a:ext cx="10469879" cy="0"/>
-          </a:xfrm>
-          <a:prstGeom prst="line">
-            <a:avLst/>
-          </a:prstGeom>
-          <a:ln w="12700">
-            <a:solidFill>
-              <a:srgbClr val="E4E4E7"/>
-            </a:solidFill>
-          </a:ln>
-          <a:effectLst/>
-        </p:spPr>
-      </p:cxnSp>
-      <p:sp>
-        <p:nvSpPr>
-          <p:cNvPr id="10" name="Oval 9"/>
-          <p:cNvSpPr/>
-          <p:nvPr/>
-        </p:nvSpPr>
-        <p:spPr>
-          <a:xfrm>
-            <a:off x="868680" y="4041648"/>
-            <a:ext cx="548640" cy="548640"/>
-          </a:xfrm>
-          <a:prstGeom prst="ellipse">
-            <a:avLst/>
-          </a:prstGeom>
-          <a:noFill/>
-          <a:ln w="16510">
-            <a:solidFill>
-              <a:srgbClr val="121316"/>
-            </a:solidFill>
-          </a:ln>
-          <a:effectLst/>
-        </p:spPr>
-        <p:txBody>
-          <a:bodyPr rtlCol="0" anchor="ctr"/>
-          <a:lstStyle/>
-          <a:p>
-            <a:pPr algn="ctr"/>
-          </a:p>
-        </p:txBody>
-      </p:sp>
-      <p:sp>
-        <p:nvSpPr>
-          <p:cNvPr id="11" name="TextBox 10"/>
-          <p:cNvSpPr txBox="1"/>
-          <p:nvPr/>
-        </p:nvSpPr>
-        <p:spPr>
-          <a:xfrm>
-            <a:off x="868680" y="4014215"/>
-            <a:ext cx="548640" cy="548640"/>
-          </a:xfrm>
-          <a:prstGeom prst="rect">
-            <a:avLst/>
-          </a:prstGeom>
-          <a:noFill/>
-        </p:spPr>
-        <p:txBody>
-          <a:bodyPr wrap="square" anchor="ctr" lIns="0" rIns="0" tIns="0" bIns="0">
-            <a:spAutoFit/>
-          </a:bodyPr>
-          <a:lstStyle/>
-          <a:p>
-            <a:pPr algn="ctr">
-              <a:spcAft>
-                <a:spcPts val="200"/>
-              </a:spcAft>
-            </a:pPr>
-            <a:r>
-              <a:rPr sz="1400" b="1" i="0">
-                <a:solidFill>
-                  <a:srgbClr val="121316"/>
-                </a:solidFill>
-                <a:latin typeface="Arial"/>
-              </a:rPr>
-              <a:t>2</a:t>
-            </a:r>
-          </a:p>
-        </p:txBody>
-      </p:sp>
-      <p:sp>
-        <p:nvSpPr>
-          <p:cNvPr id="12" name="TextBox 11"/>
-          <p:cNvSpPr txBox="1"/>
-          <p:nvPr/>
-        </p:nvSpPr>
-        <p:spPr>
-          <a:xfrm>
-            <a:off x="1737360" y="4005072"/>
-            <a:ext cx="9509760" cy="1005840"/>
-          </a:xfrm>
-          <a:prstGeom prst="rect">
-            <a:avLst/>
-          </a:prstGeom>
-          <a:noFill/>
-        </p:spPr>
-        <p:txBody>
-          <a:bodyPr wrap="square" anchor="t" lIns="0" rIns="0" tIns="0" bIns="0">
-            <a:spAutoFit/>
-          </a:bodyPr>
-          <a:lstStyle/>
-          <a:p>
-            <a:pPr algn="l">
-              <a:spcAft>
-                <a:spcPts val="300"/>
-              </a:spcAft>
-            </a:pPr>
-            <a:r>
-              <a:rPr sz="2000" b="1" i="0">
-                <a:solidFill>
-                  <a:srgbClr val="121316"/>
-                </a:solidFill>
-                <a:latin typeface="Arial"/>
-              </a:rPr>
-              <a:t>Einen Website-Auftrag bauen</a:t>
-            </a:r>
-          </a:p>
-          <a:p>
-            <a:pPr algn="l">
-              <a:spcAft>
-                <a:spcPts val="200"/>
-              </a:spcAft>
-            </a:pPr>
-            <a:r>
-              <a:rPr sz="1400" b="0" i="0">
-                <a:solidFill>
-                  <a:srgbClr val="71717A"/>
-                </a:solidFill>
-                <a:latin typeface="Arial"/>
-              </a:rPr>
-              <a:t>Mit dem Baukasten einen klaren Prompt zusammenstellen.</a:t>
-            </a:r>
-          </a:p>
-        </p:txBody>
-      </p:sp>
-      <p:cxnSp>
-        <p:nvCxnSpPr>
-          <p:cNvPr id="13" name="Connector 12"/>
-          <p:cNvCxnSpPr/>
-          <p:nvPr/>
-        </p:nvCxnSpPr>
-        <p:spPr>
-          <a:xfrm>
-            <a:off x="868680" y="5029200"/>
-            <a:ext cx="10469879" cy="0"/>
-          </a:xfrm>
-          <a:prstGeom prst="line">
-            <a:avLst/>
-          </a:prstGeom>
-          <a:ln w="12700">
-            <a:solidFill>
-              <a:srgbClr val="E4E4E7"/>
-            </a:solidFill>
-          </a:ln>
-          <a:effectLst/>
-        </p:spPr>
-      </p:cxnSp>
-      <p:sp>
-        <p:nvSpPr>
-          <p:cNvPr id="14" name="Oval 13"/>
-          <p:cNvSpPr/>
-          <p:nvPr/>
-        </p:nvSpPr>
-        <p:spPr>
-          <a:xfrm>
-            <a:off x="868680" y="5321808"/>
-            <a:ext cx="548640" cy="548640"/>
-          </a:xfrm>
-          <a:prstGeom prst="ellipse">
-            <a:avLst/>
-          </a:prstGeom>
-          <a:noFill/>
-          <a:ln w="16510">
-            <a:solidFill>
-              <a:srgbClr val="121316"/>
-            </a:solidFill>
-          </a:ln>
-          <a:effectLst/>
-        </p:spPr>
-        <p:txBody>
-          <a:bodyPr rtlCol="0" anchor="ctr"/>
-          <a:lstStyle/>
-          <a:p>
-            <a:pPr algn="ctr"/>
-          </a:p>
-        </p:txBody>
-      </p:sp>
-      <p:sp>
-        <p:nvSpPr>
-          <p:cNvPr id="15" name="TextBox 14"/>
-          <p:cNvSpPr txBox="1"/>
-          <p:nvPr/>
-        </p:nvSpPr>
-        <p:spPr>
-          <a:xfrm>
-            <a:off x="868680" y="5294376"/>
-            <a:ext cx="548640" cy="548640"/>
-          </a:xfrm>
-          <a:prstGeom prst="rect">
-            <a:avLst/>
-          </a:prstGeom>
-          <a:noFill/>
-        </p:spPr>
-        <p:txBody>
-          <a:bodyPr wrap="square" anchor="ctr" lIns="0" rIns="0" tIns="0" bIns="0">
-            <a:spAutoFit/>
-          </a:bodyPr>
-          <a:lstStyle/>
-          <a:p>
-            <a:pPr algn="ctr">
-              <a:spcAft>
-                <a:spcPts val="200"/>
-              </a:spcAft>
-            </a:pPr>
-            <a:r>
-              <a:rPr sz="1400" b="1" i="0">
-                <a:solidFill>
-                  <a:srgbClr val="121316"/>
-                </a:solidFill>
-                <a:latin typeface="Arial"/>
-              </a:rPr>
-              <a:t>3</a:t>
-            </a:r>
-          </a:p>
-        </p:txBody>
-      </p:sp>
-      <p:sp>
-        <p:nvSpPr>
-          <p:cNvPr id="16" name="TextBox 15"/>
-          <p:cNvSpPr txBox="1"/>
-          <p:nvPr/>
-        </p:nvSpPr>
-        <p:spPr>
-          <a:xfrm>
-            <a:off x="1737360" y="5285232"/>
-            <a:ext cx="9509760" cy="1005840"/>
-          </a:xfrm>
-          <a:prstGeom prst="rect">
-            <a:avLst/>
-          </a:prstGeom>
-          <a:noFill/>
-        </p:spPr>
-        <p:txBody>
-          <a:bodyPr wrap="square" anchor="t" lIns="0" rIns="0" tIns="0" bIns="0">
-            <a:spAutoFit/>
-          </a:bodyPr>
-          <a:lstStyle/>
-          <a:p>
-            <a:pPr algn="l">
-              <a:spcAft>
-                <a:spcPts val="300"/>
-              </a:spcAft>
-            </a:pPr>
-            <a:r>
-              <a:rPr sz="2000" b="1" i="0">
-                <a:solidFill>
-                  <a:srgbClr val="121316"/>
-                </a:solidFill>
-                <a:latin typeface="Arial"/>
-              </a:rPr>
-              <a:t>Eine erste Website erzeugen</a:t>
-            </a:r>
-          </a:p>
-          <a:p>
-            <a:pPr algn="l">
-              <a:spcAft>
-                <a:spcPts val="200"/>
-              </a:spcAft>
-            </a:pPr>
-            <a:r>
-              <a:rPr sz="1400" b="0" i="0">
-                <a:solidFill>
-                  <a:srgbClr val="71717A"/>
-                </a:solidFill>
-                <a:latin typeface="Arial"/>
-              </a:rPr>
-              <a:t>Prompt in AI Studio einfügen, Vorschau sehen.</a:t>
-            </a:r>
-          </a:p>
-        </p:txBody>
-      </p:sp>
-      <p:cxnSp>
-        <p:nvCxnSpPr>
-          <p:cNvPr id="17" name="Connector 16"/>
-          <p:cNvCxnSpPr/>
-          <p:nvPr/>
-        </p:nvCxnSpPr>
-        <p:spPr>
-          <a:xfrm>
-            <a:off x="868680" y="6309360"/>
-            <a:ext cx="10469879" cy="0"/>
-          </a:xfrm>
-          <a:prstGeom prst="line">
-            <a:avLst/>
-          </a:prstGeom>
-          <a:ln w="12700">
-            <a:solidFill>
-              <a:srgbClr val="E4E4E7"/>
-            </a:solidFill>
-          </a:ln>
-          <a:effectLst/>
-        </p:spPr>
-      </p:cxnSp>
+              <a:rPr sz="2700" b="1" i="0">
+                <a:solidFill>
+                  <a:srgbClr val="FFFFFF"/>
+                </a:solidFill>
+                <a:latin typeface="Arial"/>
+              </a:rPr>
+              <a:t>KI schreibt nicht nur Texte — </a:t>
+            </a:r>
+            <a:r>
+              <a:rPr sz="2700" b="1" i="0">
+                <a:solidFill>
+                  <a:srgbClr val="2563EB"/>
+                </a:solidFill>
+                <a:latin typeface="Arial"/>
+              </a:rPr>
+              <a:t>sie baut ganze Websites.</a:t>
+            </a:r>
+          </a:p>
+        </p:txBody>
+      </p:sp>
     </p:spTree>
   </p:cSld>
   <p:clrMapOvr>
@@ -6790,7 +6807,7 @@
                 </a:solidFill>
                 <a:latin typeface="Arial"/>
               </a:rPr>
-              <a:t>Kostenloses Web-Tool von Google  </a:t>
+              <a:t>Websites und kleine Apps bauen  </a:t>
             </a:r>
             <a:r>
               <a:rPr sz="1400" b="0" i="0">
@@ -6799,7 +6816,7 @@
                 </a:solidFill>
                 <a:latin typeface="Arial"/>
               </a:rPr>
-              <a:t>Build-Modus auf aistudio.google.com/apps – nichts installieren.</a:t>
+              <a:t>z. B. Portfolio, Vereinsseite, Quiz oder Rechner.</a:t>
             </a:r>
           </a:p>
         </p:txBody>
@@ -7068,7 +7085,7 @@
                 </a:solidFill>
                 <a:latin typeface="Arial"/>
               </a:rPr>
-              <a:t>Sofort sichtbar  </a:t>
+              <a:t>Kostenlos, direkt im Browser  </a:t>
             </a:r>
             <a:r>
               <a:rPr sz="1400" b="0" i="0">
@@ -7077,7 +7094,7 @@
                 </a:solidFill>
                 <a:latin typeface="Arial"/>
               </a:rPr>
-              <a:t>Die Vorschau erscheint live.</a:t>
+              <a:t>Build-Modus auf aistudio.google.com/apps – nichts installieren.</a:t>
             </a:r>
           </a:p>
         </p:txBody>
@@ -7207,7 +7224,7 @@
                 </a:solidFill>
                 <a:latin typeface="Arial"/>
               </a:rPr>
-              <a:t>Einfach anpassen  </a:t>
+              <a:t>Anschauen und anpassen  </a:t>
             </a:r>
             <a:r>
               <a:rPr sz="1400" b="0" i="0">
@@ -7216,7 +7233,7 @@
                 </a:solidFill>
                 <a:latin typeface="Arial"/>
               </a:rPr>
-              <a:t>Änderung als nächste Nachricht schreiben.</a:t>
+              <a:t>Vorschau im Browser; Änderungen als nächste Nachricht.</a:t>
             </a:r>
           </a:p>
         </p:txBody>
@@ -8010,7 +8027,7 @@
                 </a:solidFill>
                 <a:latin typeface="Arial"/>
               </a:rPr>
-              <a:t>Einfügen, abschicken – die Vorschau erscheint.</a:t>
+              <a:t>Einfügen, abschicken – die KI baut los (ein paar Minuten).</a:t>
             </a:r>
           </a:p>
         </p:txBody>
@@ -8632,7 +8649,7 @@
                 </a:solidFill>
                 <a:latin typeface="Arial"/>
               </a:rPr>
-              <a:t>Die Generierung dauert ein paar Minuten — starten, nicht warten. Ergebnis später im Gruppenchat teilen.</a:t>
+              <a:t>Starten — und während es baut, kurz austauschen. Den Link teilt ihr später im Gruppenchat.</a:t>
             </a:r>
           </a:p>
         </p:txBody>
@@ -8725,23 +8742,7 @@
                 </a:solidFill>
                 <a:latin typeface="Arial"/>
               </a:rPr>
-              <a:t>criseone.github.io/</a:t>
-            </a:r>
-          </a:p>
-          <a:p>
-            <a:pPr algn="ctr">
-              <a:spcAft>
-                <a:spcPts val="200"/>
-              </a:spcAft>
-            </a:pPr>
-            <a:r>
-              <a:rPr sz="1150" b="1" i="0">
-                <a:solidFill>
-                  <a:srgbClr val="121316"/>
-                </a:solidFill>
-                <a:latin typeface="Arial"/>
-              </a:rPr>
-              <a:t>meine-website-ai-studio</a:t>
+              <a:t>tinyurl.com/website-baukasten</a:t>
             </a:r>
           </a:p>
         </p:txBody>
@@ -9170,7 +9171,41 @@
                 </a:solidFill>
                 <a:latin typeface="Arial"/>
               </a:rPr>
-              <a:t>Fragen? Dann: selbst weiterprobieren.</a:t>
+              <a:t>Fragen? Jetzt ist der beste Moment.</a:t>
+            </a:r>
+          </a:p>
+        </p:txBody>
+      </p:sp>
+      <p:sp>
+        <p:nvSpPr>
+          <p:cNvPr id="12" name="TextBox 11"/>
+          <p:cNvSpPr txBox="1"/>
+          <p:nvPr/>
+        </p:nvSpPr>
+        <p:spPr>
+          <a:xfrm>
+            <a:off x="868680" y="1938528"/>
+            <a:ext cx="10469880" cy="411480"/>
+          </a:xfrm>
+          <a:prstGeom prst="rect">
+            <a:avLst/>
+          </a:prstGeom>
+          <a:noFill/>
+        </p:spPr>
+        <p:txBody>
+          <a:bodyPr wrap="square" lIns="0" rIns="0" tIns="0" bIns="0">
+            <a:spAutoFit/>
+          </a:bodyPr>
+          <a:lstStyle/>
+          <a:p>
+            <a:r>
+              <a:rPr sz="1500" b="1">
+                <a:solidFill>
+                  <a:srgbClr val="2563EB"/>
+                </a:solidFill>
+                <a:latin typeface="Arial"/>
+              </a:rPr>
+              <a:t>Während eure Websites bauen, schauen wir kurz, was hängen geblieben ist.</a:t>
             </a:r>
           </a:p>
         </p:txBody>

</xml_diff>